<commit_message>
Make indicators slide a single continuous list
Co-Authored-By: Claude Sonnet 5.5 <noreply@anthropic.com>
Claude-Session: https://claude.ai/code/session_01PfagTkBBfn3ShTm5bX9M45
</commit_message>
<xml_diff>
--- a/slide_pokazateli_struktura_ekonomiki.pptx
+++ b/slide_pokazateli_struktura_ekonomiki.pptx
@@ -430,7 +430,7 @@
           <a:lstStyle/>
           <a:p>
             <a:r>
-              <a:t>Слайд вставляется перед диаграммой Севастополя и России. Перечень составлен по содержимому слайдов 25 и 26 презентации. Колонка источников данных не добавлена: в презентации они для этих слайдов не указаны, их нужно добавить после сверки (для Севастополя ВРП и занятость по видам деятельности обычно берутся из статистики Росстата).</a:t>
+              <a:t>Единый перечень составлен по содержимому слайдов 25 и 26 презентации (Севастополь, Ноябрьск), без привязки к конкретным слайдам. Колонка источников данных не добавлена: в презентации они для этих слайдов не указаны, их нужно добавить после сверки (для Севастополя ВРП и занятость по видам деятельности обычно берутся из статистики Росстата).</a:t>
             </a:r>
           </a:p>
         </p:txBody>
@@ -6289,7 +6289,7 @@
                 </a:solidFill>
                 <a:latin typeface="Circe"/>
               </a:rPr>
-              <a:t>Из этих показателей построены диаграмма Севастополя и России и анализ экономики Ноябрьска</a:t>
+              <a:t>Занятость, продукт и производительность труда по видам деятельности и итоги по территории</a:t>
             </a:r>
             <a:endParaRPr sz="2200" b="0" dirty="0">
               <a:solidFill>
@@ -6425,43 +6425,14 @@
       </p:cxnSp>
       <p:sp>
         <p:nvSpPr>
-          <p:cNvPr id="207" name="Группа"/>
-          <p:cNvSpPr/>
-          <p:nvPr/>
-        </p:nvSpPr>
-        <p:spPr>
-          <a:xfrm>
-            <a:off x="1069848" y="2587752"/>
-            <a:ext cx="16870680" cy="402336"/>
-          </a:xfrm>
-          <a:prstGeom prst="rect">
-            <a:avLst/>
-          </a:prstGeom>
-          <a:solidFill>
-            <a:srgbClr val="FFF3CC"/>
-          </a:solidFill>
-          <a:ln>
-            <a:noFill/>
-          </a:ln>
-        </p:spPr>
-        <p:txBody>
-          <a:bodyPr rtlCol="0" anchor="ctr"/>
-          <a:lstStyle/>
-          <a:p>
-            <a:pPr algn="ctr"/>
-          </a:p>
-        </p:txBody>
-      </p:sp>
-      <p:sp>
-        <p:nvSpPr>
-          <p:cNvPr id="208" name="Текст"/>
+          <p:cNvPr id="207" name="Текст"/>
           <p:cNvSpPr txBox="1"/>
           <p:nvPr/>
         </p:nvSpPr>
         <p:spPr>
           <a:xfrm>
-            <a:off x="1417320" y="2587752"/>
-            <a:ext cx="16322039" cy="402336"/>
+            <a:off x="1417320" y="2624328"/>
+            <a:ext cx="6766560" cy="658368"/>
           </a:xfrm>
           <a:prstGeom prst="rect">
             <a:avLst/>
@@ -6475,41 +6446,7 @@
           <a:lstStyle/>
           <a:p>
             <a:r>
-              <a:rPr sz="1500" b="1">
-                <a:solidFill>
-                  <a:srgbClr val="062D3F"/>
-                </a:solidFill>
-                <a:latin typeface="Circe Bold"/>
-              </a:rPr>
-              <a:t>СЕВАСТОПОЛЬ И РОССИЯ, ПО ВИДАМ ДЕЯТЕЛЬНОСТИ</a:t>
-            </a:r>
-          </a:p>
-        </p:txBody>
-      </p:sp>
-      <p:sp>
-        <p:nvSpPr>
-          <p:cNvPr id="209" name="Текст"/>
-          <p:cNvSpPr txBox="1"/>
-          <p:nvPr/>
-        </p:nvSpPr>
-        <p:spPr>
-          <a:xfrm>
-            <a:off x="1417320" y="2990088"/>
-            <a:ext cx="6766560" cy="448056"/>
-          </a:xfrm>
-          <a:prstGeom prst="rect">
-            <a:avLst/>
-          </a:prstGeom>
-          <a:noFill/>
-        </p:spPr>
-        <p:txBody>
-          <a:bodyPr wrap="square" anchor="ctr" lIns="0" rIns="0" tIns="0" bIns="0">
-            <a:spAutoFit/>
-          </a:bodyPr>
-          <a:lstStyle/>
-          <a:p>
-            <a:r>
-              <a:rPr sz="1600" b="1">
+              <a:rPr sz="1700" b="1">
                 <a:solidFill>
                   <a:srgbClr val="062D3F"/>
                 </a:solidFill>
@@ -6522,14 +6459,14 @@
       </p:sp>
       <p:sp>
         <p:nvSpPr>
-          <p:cNvPr id="210" name="Текст"/>
+          <p:cNvPr id="208" name="Текст"/>
           <p:cNvSpPr txBox="1"/>
           <p:nvPr/>
         </p:nvSpPr>
         <p:spPr>
           <a:xfrm>
-            <a:off x="8412480" y="2990088"/>
-            <a:ext cx="3566160" cy="448056"/>
+            <a:off x="8412480" y="2624328"/>
+            <a:ext cx="3566160" cy="658368"/>
           </a:xfrm>
           <a:prstGeom prst="rect">
             <a:avLst/>
@@ -6543,27 +6480,27 @@
           <a:lstStyle/>
           <a:p>
             <a:r>
-              <a:rPr sz="1500" b="0">
+              <a:rPr sz="1600" b="0">
                 <a:solidFill>
                   <a:srgbClr val="5E6B73"/>
                 </a:solidFill>
                 <a:latin typeface="Circe"/>
               </a:rPr>
-              <a:t>% от числа занятых</a:t>
+              <a:t>% от числа занятых, тыс. чел.</a:t>
             </a:r>
           </a:p>
         </p:txBody>
       </p:sp>
       <p:sp>
         <p:nvSpPr>
-          <p:cNvPr id="211" name="Текст"/>
+          <p:cNvPr id="209" name="Текст"/>
           <p:cNvSpPr txBox="1"/>
           <p:nvPr/>
         </p:nvSpPr>
         <p:spPr>
           <a:xfrm>
-            <a:off x="12252960" y="2990088"/>
-            <a:ext cx="5303520" cy="448056"/>
+            <a:off x="12252960" y="2624328"/>
+            <a:ext cx="5303520" cy="658368"/>
           </a:xfrm>
           <a:prstGeom prst="rect">
             <a:avLst/>
@@ -6577,26 +6514,26 @@
           <a:lstStyle/>
           <a:p>
             <a:r>
-              <a:rPr sz="1500" b="0">
+              <a:rPr sz="1600" b="0">
                 <a:solidFill>
                   <a:srgbClr val="062D3F"/>
                 </a:solidFill>
                 <a:latin typeface="Circe"/>
               </a:rPr>
-              <a:t>Структура занятости, 19 видов деятельности</a:t>
+              <a:t>Структура занятости по видам деятельности</a:t>
             </a:r>
           </a:p>
         </p:txBody>
       </p:sp>
       <p:cxnSp>
         <p:nvCxnSpPr>
-          <p:cNvPr id="212" name="Разделитель"/>
+          <p:cNvPr id="210" name="Разделитель"/>
           <p:cNvCxnSpPr/>
           <p:nvPr/>
         </p:nvCxnSpPr>
         <p:spPr>
           <a:xfrm>
-            <a:off x="1069848" y="3438144"/>
+            <a:off x="1069848" y="3282696"/>
             <a:ext cx="16870679" cy="0"/>
           </a:xfrm>
           <a:prstGeom prst="line">
@@ -6611,14 +6548,14 @@
       </p:cxnSp>
       <p:sp>
         <p:nvSpPr>
-          <p:cNvPr id="213" name="Текст"/>
+          <p:cNvPr id="211" name="Текст"/>
           <p:cNvSpPr txBox="1"/>
           <p:nvPr/>
         </p:nvSpPr>
         <p:spPr>
           <a:xfrm>
-            <a:off x="1417320" y="3438144"/>
-            <a:ext cx="6766560" cy="448056"/>
+            <a:off x="1417320" y="3282696"/>
+            <a:ext cx="6766560" cy="658368"/>
           </a:xfrm>
           <a:prstGeom prst="rect">
             <a:avLst/>
@@ -6632,27 +6569,27 @@
           <a:lstStyle/>
           <a:p>
             <a:r>
-              <a:rPr sz="1600" b="1">
+              <a:rPr sz="1700" b="1">
                 <a:solidFill>
                   <a:srgbClr val="062D3F"/>
                 </a:solidFill>
                 <a:latin typeface="Circe Bold"/>
               </a:rPr>
-              <a:t>Валовой региональный продукт</a:t>
+              <a:t>Валовой региональный (городской) продукт по видам деятельности</a:t>
             </a:r>
           </a:p>
         </p:txBody>
       </p:sp>
       <p:sp>
         <p:nvSpPr>
-          <p:cNvPr id="214" name="Текст"/>
+          <p:cNvPr id="212" name="Текст"/>
           <p:cNvSpPr txBox="1"/>
           <p:nvPr/>
         </p:nvSpPr>
         <p:spPr>
           <a:xfrm>
-            <a:off x="8412480" y="3438144"/>
-            <a:ext cx="3566160" cy="448056"/>
+            <a:off x="8412480" y="3282696"/>
+            <a:ext cx="3566160" cy="658368"/>
           </a:xfrm>
           <a:prstGeom prst="rect">
             <a:avLst/>
@@ -6666,27 +6603,27 @@
           <a:lstStyle/>
           <a:p>
             <a:r>
-              <a:rPr sz="1500" b="0">
+              <a:rPr sz="1600" b="0">
                 <a:solidFill>
                   <a:srgbClr val="5E6B73"/>
                 </a:solidFill>
                 <a:latin typeface="Circe"/>
               </a:rPr>
-              <a:t>% от общего объёма</a:t>
+              <a:t>% от общего объёма, млрд руб.</a:t>
             </a:r>
           </a:p>
         </p:txBody>
       </p:sp>
       <p:sp>
         <p:nvSpPr>
-          <p:cNvPr id="215" name="Текст"/>
+          <p:cNvPr id="213" name="Текст"/>
           <p:cNvSpPr txBox="1"/>
           <p:nvPr/>
         </p:nvSpPr>
         <p:spPr>
           <a:xfrm>
-            <a:off x="12252960" y="3438144"/>
-            <a:ext cx="5303520" cy="448056"/>
+            <a:off x="12252960" y="3282696"/>
+            <a:ext cx="5303520" cy="658368"/>
           </a:xfrm>
           <a:prstGeom prst="rect">
             <a:avLst/>
@@ -6700,26 +6637,26 @@
           <a:lstStyle/>
           <a:p>
             <a:r>
-              <a:rPr sz="1500" b="0">
+              <a:rPr sz="1600" b="0">
                 <a:solidFill>
                   <a:srgbClr val="062D3F"/>
                 </a:solidFill>
                 <a:latin typeface="Circe"/>
               </a:rPr>
-              <a:t>Структура ВРП по тем же видам деятельности</a:t>
+              <a:t>Структура продукта по тем же видам деятельности</a:t>
             </a:r>
           </a:p>
         </p:txBody>
       </p:sp>
       <p:cxnSp>
         <p:nvCxnSpPr>
-          <p:cNvPr id="216" name="Разделитель"/>
+          <p:cNvPr id="214" name="Разделитель"/>
           <p:cNvCxnSpPr/>
           <p:nvPr/>
         </p:nvCxnSpPr>
         <p:spPr>
           <a:xfrm>
-            <a:off x="1069848" y="3886200"/>
+            <a:off x="1069848" y="3941063"/>
             <a:ext cx="16870679" cy="0"/>
           </a:xfrm>
           <a:prstGeom prst="line">
@@ -6734,14 +6671,14 @@
       </p:cxnSp>
       <p:sp>
         <p:nvSpPr>
-          <p:cNvPr id="217" name="Текст"/>
+          <p:cNvPr id="215" name="Текст"/>
           <p:cNvSpPr txBox="1"/>
           <p:nvPr/>
         </p:nvSpPr>
         <p:spPr>
           <a:xfrm>
-            <a:off x="1417320" y="3886200"/>
-            <a:ext cx="6766560" cy="448056"/>
+            <a:off x="1417320" y="3941063"/>
+            <a:ext cx="6766560" cy="658368"/>
           </a:xfrm>
           <a:prstGeom prst="rect">
             <a:avLst/>
@@ -6755,27 +6692,27 @@
           <a:lstStyle/>
           <a:p>
             <a:r>
-              <a:rPr sz="1600" b="1">
+              <a:rPr sz="1700" b="1">
                 <a:solidFill>
                   <a:srgbClr val="062D3F"/>
                 </a:solidFill>
                 <a:latin typeface="Circe Bold"/>
               </a:rPr>
-              <a:t>Производительность труда</a:t>
+              <a:t>Производительность труда по видам деятельности</a:t>
             </a:r>
           </a:p>
         </p:txBody>
       </p:sp>
       <p:sp>
         <p:nvSpPr>
-          <p:cNvPr id="218" name="Текст"/>
+          <p:cNvPr id="216" name="Текст"/>
           <p:cNvSpPr txBox="1"/>
           <p:nvPr/>
         </p:nvSpPr>
         <p:spPr>
           <a:xfrm>
-            <a:off x="8412480" y="3886200"/>
-            <a:ext cx="3566160" cy="448056"/>
+            <a:off x="8412480" y="3941063"/>
+            <a:ext cx="3566160" cy="658368"/>
           </a:xfrm>
           <a:prstGeom prst="rect">
             <a:avLst/>
@@ -6789,7 +6726,7 @@
           <a:lstStyle/>
           <a:p>
             <a:r>
-              <a:rPr sz="1500" b="0">
+              <a:rPr sz="1600" b="0">
                 <a:solidFill>
                   <a:srgbClr val="5E6B73"/>
                 </a:solidFill>
@@ -6802,14 +6739,14 @@
       </p:sp>
       <p:sp>
         <p:nvSpPr>
-          <p:cNvPr id="219" name="Текст"/>
+          <p:cNvPr id="217" name="Текст"/>
           <p:cNvSpPr txBox="1"/>
           <p:nvPr/>
         </p:nvSpPr>
         <p:spPr>
           <a:xfrm>
-            <a:off x="12252960" y="3886200"/>
-            <a:ext cx="5303520" cy="448056"/>
+            <a:off x="12252960" y="3941063"/>
+            <a:ext cx="5303520" cy="658368"/>
           </a:xfrm>
           <a:prstGeom prst="rect">
             <a:avLst/>
@@ -6823,26 +6760,26 @@
           <a:lstStyle/>
           <a:p>
             <a:r>
-              <a:rPr sz="1500" b="0">
+              <a:rPr sz="1600" b="0">
                 <a:solidFill>
                   <a:srgbClr val="062D3F"/>
                 </a:solidFill>
                 <a:latin typeface="Circe"/>
               </a:rPr>
-              <a:t>ВРП вида деятельности на одного занятого в нём</a:t>
+              <a:t>Продукт вида деятельности на одного занятого в нём</a:t>
             </a:r>
           </a:p>
         </p:txBody>
       </p:sp>
       <p:cxnSp>
         <p:nvCxnSpPr>
-          <p:cNvPr id="220" name="Разделитель"/>
+          <p:cNvPr id="218" name="Разделитель"/>
           <p:cNvCxnSpPr/>
           <p:nvPr/>
         </p:nvCxnSpPr>
         <p:spPr>
           <a:xfrm>
-            <a:off x="1069848" y="4334256"/>
+            <a:off x="1069848" y="4599431"/>
             <a:ext cx="16870679" cy="0"/>
           </a:xfrm>
           <a:prstGeom prst="line">
@@ -6857,43 +6794,14 @@
       </p:cxnSp>
       <p:sp>
         <p:nvSpPr>
-          <p:cNvPr id="221" name="Группа"/>
-          <p:cNvSpPr/>
-          <p:nvPr/>
-        </p:nvSpPr>
-        <p:spPr>
-          <a:xfrm>
-            <a:off x="1069848" y="4361688"/>
-            <a:ext cx="16870680" cy="402336"/>
-          </a:xfrm>
-          <a:prstGeom prst="rect">
-            <a:avLst/>
-          </a:prstGeom>
-          <a:solidFill>
-            <a:srgbClr val="FFF3CC"/>
-          </a:solidFill>
-          <a:ln>
-            <a:noFill/>
-          </a:ln>
-        </p:spPr>
-        <p:txBody>
-          <a:bodyPr rtlCol="0" anchor="ctr"/>
-          <a:lstStyle/>
-          <a:p>
-            <a:pPr algn="ctr"/>
-          </a:p>
-        </p:txBody>
-      </p:sp>
-      <p:sp>
-        <p:nvSpPr>
-          <p:cNvPr id="222" name="Текст"/>
+          <p:cNvPr id="219" name="Текст"/>
           <p:cNvSpPr txBox="1"/>
           <p:nvPr/>
         </p:nvSpPr>
         <p:spPr>
           <a:xfrm>
-            <a:off x="1417320" y="4361688"/>
-            <a:ext cx="16322039" cy="402336"/>
+            <a:off x="1417320" y="4599431"/>
+            <a:ext cx="6766560" cy="658368"/>
           </a:xfrm>
           <a:prstGeom prst="rect">
             <a:avLst/>
@@ -6907,41 +6815,7 @@
           <a:lstStyle/>
           <a:p>
             <a:r>
-              <a:rPr sz="1500" b="1">
-                <a:solidFill>
-                  <a:srgbClr val="062D3F"/>
-                </a:solidFill>
-                <a:latin typeface="Circe Bold"/>
-              </a:rPr>
-              <a:t>СЕВАСТОПОЛЬ И РОССИЯ, ИТОГИ ПО ТЕРРИТОРИИ</a:t>
-            </a:r>
-          </a:p>
-        </p:txBody>
-      </p:sp>
-      <p:sp>
-        <p:nvSpPr>
-          <p:cNvPr id="223" name="Текст"/>
-          <p:cNvSpPr txBox="1"/>
-          <p:nvPr/>
-        </p:nvSpPr>
-        <p:spPr>
-          <a:xfrm>
-            <a:off x="1417320" y="4764024"/>
-            <a:ext cx="6766560" cy="448056"/>
-          </a:xfrm>
-          <a:prstGeom prst="rect">
-            <a:avLst/>
-          </a:prstGeom>
-          <a:noFill/>
-        </p:spPr>
-        <p:txBody>
-          <a:bodyPr wrap="square" anchor="ctr" lIns="0" rIns="0" tIns="0" bIns="0">
-            <a:spAutoFit/>
-          </a:bodyPr>
-          <a:lstStyle/>
-          <a:p>
-            <a:r>
-              <a:rPr sz="1600" b="1">
+              <a:rPr sz="1700" b="1">
                 <a:solidFill>
                   <a:srgbClr val="062D3F"/>
                 </a:solidFill>
@@ -6954,14 +6828,14 @@
       </p:sp>
       <p:sp>
         <p:nvSpPr>
-          <p:cNvPr id="224" name="Текст"/>
+          <p:cNvPr id="220" name="Текст"/>
           <p:cNvSpPr txBox="1"/>
           <p:nvPr/>
         </p:nvSpPr>
         <p:spPr>
           <a:xfrm>
-            <a:off x="8412480" y="4764024"/>
-            <a:ext cx="3566160" cy="448056"/>
+            <a:off x="8412480" y="4599431"/>
+            <a:ext cx="3566160" cy="658368"/>
           </a:xfrm>
           <a:prstGeom prst="rect">
             <a:avLst/>
@@ -6975,7 +6849,7 @@
           <a:lstStyle/>
           <a:p>
             <a:r>
-              <a:rPr sz="1500" b="0">
+              <a:rPr sz="1600" b="0">
                 <a:solidFill>
                   <a:srgbClr val="5E6B73"/>
                 </a:solidFill>
@@ -6988,14 +6862,14 @@
       </p:sp>
       <p:sp>
         <p:nvSpPr>
-          <p:cNvPr id="225" name="Текст"/>
+          <p:cNvPr id="221" name="Текст"/>
           <p:cNvSpPr txBox="1"/>
           <p:nvPr/>
         </p:nvSpPr>
         <p:spPr>
           <a:xfrm>
-            <a:off x="12252960" y="4764024"/>
-            <a:ext cx="5303520" cy="448056"/>
+            <a:off x="12252960" y="4599431"/>
+            <a:ext cx="5303520" cy="658368"/>
           </a:xfrm>
           <a:prstGeom prst="rect">
             <a:avLst/>
@@ -7009,26 +6883,26 @@
           <a:lstStyle/>
           <a:p>
             <a:r>
-              <a:rPr sz="1500" b="0">
+              <a:rPr sz="1600" b="0">
                 <a:solidFill>
                   <a:srgbClr val="062D3F"/>
                 </a:solidFill>
                 <a:latin typeface="Circe"/>
               </a:rPr>
-              <a:t>Значение за 2021 год и рост с 2015 года</a:t>
+              <a:t>Значение за год и рост за период</a:t>
             </a:r>
           </a:p>
         </p:txBody>
       </p:sp>
       <p:cxnSp>
         <p:nvCxnSpPr>
-          <p:cNvPr id="226" name="Разделитель"/>
+          <p:cNvPr id="222" name="Разделитель"/>
           <p:cNvCxnSpPr/>
           <p:nvPr/>
         </p:nvCxnSpPr>
         <p:spPr>
           <a:xfrm>
-            <a:off x="1069848" y="5212080"/>
+            <a:off x="1069848" y="5257799"/>
             <a:ext cx="16870679" cy="0"/>
           </a:xfrm>
           <a:prstGeom prst="line">
@@ -7043,14 +6917,14 @@
       </p:cxnSp>
       <p:sp>
         <p:nvSpPr>
-          <p:cNvPr id="227" name="Текст"/>
+          <p:cNvPr id="223" name="Текст"/>
           <p:cNvSpPr txBox="1"/>
           <p:nvPr/>
         </p:nvSpPr>
         <p:spPr>
           <a:xfrm>
-            <a:off x="1417320" y="5212080"/>
-            <a:ext cx="6766560" cy="448056"/>
+            <a:off x="1417320" y="5257799"/>
+            <a:ext cx="6766560" cy="658368"/>
           </a:xfrm>
           <a:prstGeom prst="rect">
             <a:avLst/>
@@ -7064,7 +6938,7 @@
           <a:lstStyle/>
           <a:p>
             <a:r>
-              <a:rPr sz="1600" b="1">
+              <a:rPr sz="1700" b="1">
                 <a:solidFill>
                   <a:srgbClr val="062D3F"/>
                 </a:solidFill>
@@ -7077,14 +6951,14 @@
       </p:sp>
       <p:sp>
         <p:nvSpPr>
-          <p:cNvPr id="228" name="Текст"/>
+          <p:cNvPr id="224" name="Текст"/>
           <p:cNvSpPr txBox="1"/>
           <p:nvPr/>
         </p:nvSpPr>
         <p:spPr>
           <a:xfrm>
-            <a:off x="8412480" y="5212080"/>
-            <a:ext cx="3566160" cy="448056"/>
+            <a:off x="8412480" y="5257799"/>
+            <a:ext cx="3566160" cy="658368"/>
           </a:xfrm>
           <a:prstGeom prst="rect">
             <a:avLst/>
@@ -7098,7 +6972,7 @@
           <a:lstStyle/>
           <a:p>
             <a:r>
-              <a:rPr sz="1500" b="0">
+              <a:rPr sz="1600" b="0">
                 <a:solidFill>
                   <a:srgbClr val="5E6B73"/>
                 </a:solidFill>
@@ -7111,14 +6985,14 @@
       </p:sp>
       <p:sp>
         <p:nvSpPr>
-          <p:cNvPr id="229" name="Текст"/>
+          <p:cNvPr id="225" name="Текст"/>
           <p:cNvSpPr txBox="1"/>
           <p:nvPr/>
         </p:nvSpPr>
         <p:spPr>
           <a:xfrm>
-            <a:off x="12252960" y="5212080"/>
-            <a:ext cx="5303520" cy="448056"/>
+            <a:off x="12252960" y="5257799"/>
+            <a:ext cx="5303520" cy="658368"/>
           </a:xfrm>
           <a:prstGeom prst="rect">
             <a:avLst/>
@@ -7132,7 +7006,7 @@
           <a:lstStyle/>
           <a:p>
             <a:r>
-              <a:rPr sz="1500" b="0">
+              <a:rPr sz="1600" b="0">
                 <a:solidFill>
                   <a:srgbClr val="062D3F"/>
                 </a:solidFill>
@@ -7145,13 +7019,13 @@
       </p:sp>
       <p:cxnSp>
         <p:nvCxnSpPr>
-          <p:cNvPr id="230" name="Разделитель"/>
+          <p:cNvPr id="226" name="Разделитель"/>
           <p:cNvCxnSpPr/>
           <p:nvPr/>
         </p:nvCxnSpPr>
         <p:spPr>
           <a:xfrm>
-            <a:off x="1069848" y="5660136"/>
+            <a:off x="1069848" y="5916167"/>
             <a:ext cx="16870679" cy="0"/>
           </a:xfrm>
           <a:prstGeom prst="line">
@@ -7166,14 +7040,14 @@
       </p:cxnSp>
       <p:sp>
         <p:nvSpPr>
-          <p:cNvPr id="231" name="Текст"/>
+          <p:cNvPr id="227" name="Текст"/>
           <p:cNvSpPr txBox="1"/>
           <p:nvPr/>
         </p:nvSpPr>
         <p:spPr>
           <a:xfrm>
-            <a:off x="1417320" y="5660136"/>
-            <a:ext cx="6766560" cy="448056"/>
+            <a:off x="1417320" y="5916167"/>
+            <a:ext cx="6766560" cy="658368"/>
           </a:xfrm>
           <a:prstGeom prst="rect">
             <a:avLst/>
@@ -7187,7 +7061,7 @@
           <a:lstStyle/>
           <a:p>
             <a:r>
-              <a:rPr sz="1600" b="1">
+              <a:rPr sz="1700" b="1">
                 <a:solidFill>
                   <a:srgbClr val="062D3F"/>
                 </a:solidFill>
@@ -7200,14 +7074,14 @@
       </p:sp>
       <p:sp>
         <p:nvSpPr>
-          <p:cNvPr id="232" name="Текст"/>
+          <p:cNvPr id="228" name="Текст"/>
           <p:cNvSpPr txBox="1"/>
           <p:nvPr/>
         </p:nvSpPr>
         <p:spPr>
           <a:xfrm>
-            <a:off x="8412480" y="5660136"/>
-            <a:ext cx="3566160" cy="448056"/>
+            <a:off x="8412480" y="5916167"/>
+            <a:ext cx="3566160" cy="658368"/>
           </a:xfrm>
           <a:prstGeom prst="rect">
             <a:avLst/>
@@ -7221,7 +7095,7 @@
           <a:lstStyle/>
           <a:p>
             <a:r>
-              <a:rPr sz="1500" b="0">
+              <a:rPr sz="1600" b="0">
                 <a:solidFill>
                   <a:srgbClr val="5E6B73"/>
                 </a:solidFill>
@@ -7234,14 +7108,14 @@
       </p:sp>
       <p:sp>
         <p:nvSpPr>
-          <p:cNvPr id="233" name="Текст"/>
+          <p:cNvPr id="229" name="Текст"/>
           <p:cNvSpPr txBox="1"/>
           <p:nvPr/>
         </p:nvSpPr>
         <p:spPr>
           <a:xfrm>
-            <a:off x="12252960" y="5660136"/>
-            <a:ext cx="5303520" cy="448056"/>
+            <a:off x="12252960" y="5916167"/>
+            <a:ext cx="5303520" cy="658368"/>
           </a:xfrm>
           <a:prstGeom prst="rect">
             <a:avLst/>
@@ -7255,7 +7129,7 @@
           <a:lstStyle/>
           <a:p>
             <a:r>
-              <a:rPr sz="1500" b="0">
+              <a:rPr sz="1600" b="0">
                 <a:solidFill>
                   <a:srgbClr val="062D3F"/>
                 </a:solidFill>
@@ -7268,13 +7142,13 @@
       </p:sp>
       <p:cxnSp>
         <p:nvCxnSpPr>
-          <p:cNvPr id="234" name="Разделитель"/>
+          <p:cNvPr id="230" name="Разделитель"/>
           <p:cNvCxnSpPr/>
           <p:nvPr/>
         </p:nvCxnSpPr>
         <p:spPr>
           <a:xfrm>
-            <a:off x="1069848" y="6108192"/>
+            <a:off x="1069848" y="6574535"/>
             <a:ext cx="16870679" cy="0"/>
           </a:xfrm>
           <a:prstGeom prst="line">
@@ -7289,14 +7163,14 @@
       </p:cxnSp>
       <p:sp>
         <p:nvSpPr>
-          <p:cNvPr id="235" name="Текст"/>
+          <p:cNvPr id="231" name="Текст"/>
           <p:cNvSpPr txBox="1"/>
           <p:nvPr/>
         </p:nvSpPr>
         <p:spPr>
           <a:xfrm>
-            <a:off x="1417320" y="6108192"/>
-            <a:ext cx="6766560" cy="448056"/>
+            <a:off x="1417320" y="6574535"/>
+            <a:ext cx="6766560" cy="658368"/>
           </a:xfrm>
           <a:prstGeom prst="rect">
             <a:avLst/>
@@ -7310,7 +7184,7 @@
           <a:lstStyle/>
           <a:p>
             <a:r>
-              <a:rPr sz="1600" b="1">
+              <a:rPr sz="1700" b="1">
                 <a:solidFill>
                   <a:srgbClr val="062D3F"/>
                 </a:solidFill>
@@ -7323,14 +7197,14 @@
       </p:sp>
       <p:sp>
         <p:nvSpPr>
-          <p:cNvPr id="236" name="Текст"/>
+          <p:cNvPr id="232" name="Текст"/>
           <p:cNvSpPr txBox="1"/>
           <p:nvPr/>
         </p:nvSpPr>
         <p:spPr>
           <a:xfrm>
-            <a:off x="8412480" y="6108192"/>
-            <a:ext cx="3566160" cy="448056"/>
+            <a:off x="8412480" y="6574535"/>
+            <a:ext cx="3566160" cy="658368"/>
           </a:xfrm>
           <a:prstGeom prst="rect">
             <a:avLst/>
@@ -7344,7 +7218,7 @@
           <a:lstStyle/>
           <a:p>
             <a:r>
-              <a:rPr sz="1500" b="0">
+              <a:rPr sz="1600" b="0">
                 <a:solidFill>
                   <a:srgbClr val="5E6B73"/>
                 </a:solidFill>
@@ -7357,14 +7231,14 @@
       </p:sp>
       <p:sp>
         <p:nvSpPr>
-          <p:cNvPr id="237" name="Текст"/>
+          <p:cNvPr id="233" name="Текст"/>
           <p:cNvSpPr txBox="1"/>
           <p:nvPr/>
         </p:nvSpPr>
         <p:spPr>
           <a:xfrm>
-            <a:off x="12252960" y="6108192"/>
-            <a:ext cx="5303520" cy="448056"/>
+            <a:off x="12252960" y="6574535"/>
+            <a:ext cx="5303520" cy="658368"/>
           </a:xfrm>
           <a:prstGeom prst="rect">
             <a:avLst/>
@@ -7378,7 +7252,7 @@
           <a:lstStyle/>
           <a:p>
             <a:r>
-              <a:rPr sz="1500" b="0">
+              <a:rPr sz="1600" b="0">
                 <a:solidFill>
                   <a:srgbClr val="062D3F"/>
                 </a:solidFill>
@@ -7391,13 +7265,13 @@
       </p:sp>
       <p:cxnSp>
         <p:nvCxnSpPr>
-          <p:cNvPr id="238" name="Разделитель"/>
+          <p:cNvPr id="234" name="Разделитель"/>
           <p:cNvCxnSpPr/>
           <p:nvPr/>
         </p:nvCxnSpPr>
         <p:spPr>
           <a:xfrm>
-            <a:off x="1069848" y="6556248"/>
+            <a:off x="1069848" y="7232903"/>
             <a:ext cx="16870679" cy="0"/>
           </a:xfrm>
           <a:prstGeom prst="line">
@@ -7412,43 +7286,14 @@
       </p:cxnSp>
       <p:sp>
         <p:nvSpPr>
-          <p:cNvPr id="239" name="Группа"/>
-          <p:cNvSpPr/>
-          <p:nvPr/>
-        </p:nvSpPr>
-        <p:spPr>
-          <a:xfrm>
-            <a:off x="1069848" y="6583680"/>
-            <a:ext cx="16870680" cy="402336"/>
-          </a:xfrm>
-          <a:prstGeom prst="rect">
-            <a:avLst/>
-          </a:prstGeom>
-          <a:solidFill>
-            <a:srgbClr val="FFF3CC"/>
-          </a:solidFill>
-          <a:ln>
-            <a:noFill/>
-          </a:ln>
-        </p:spPr>
-        <p:txBody>
-          <a:bodyPr rtlCol="0" anchor="ctr"/>
-          <a:lstStyle/>
-          <a:p>
-            <a:pPr algn="ctr"/>
-          </a:p>
-        </p:txBody>
-      </p:sp>
-      <p:sp>
-        <p:nvSpPr>
-          <p:cNvPr id="240" name="Текст"/>
+          <p:cNvPr id="235" name="Текст"/>
           <p:cNvSpPr txBox="1"/>
           <p:nvPr/>
         </p:nvSpPr>
         <p:spPr>
           <a:xfrm>
-            <a:off x="1417320" y="6583680"/>
-            <a:ext cx="16322039" cy="402336"/>
+            <a:off x="1417320" y="7232903"/>
+            <a:ext cx="6766560" cy="658368"/>
           </a:xfrm>
           <a:prstGeom prst="rect">
             <a:avLst/>
@@ -7462,27 +7307,27 @@
           <a:lstStyle/>
           <a:p>
             <a:r>
-              <a:rPr sz="1500" b="1">
+              <a:rPr sz="1700" b="1">
                 <a:solidFill>
                   <a:srgbClr val="062D3F"/>
                 </a:solidFill>
                 <a:latin typeface="Circe Bold"/>
               </a:rPr>
-              <a:t>НОЯБРЬСК, СУЩЕСТВУЮЩЕЕ ПОЛОЖЕНИЕ И ПРОГНОЗ К 2035 ГОДУ</a:t>
+              <a:t>Численность населения</a:t>
             </a:r>
           </a:p>
         </p:txBody>
       </p:sp>
       <p:sp>
         <p:nvSpPr>
-          <p:cNvPr id="241" name="Текст"/>
+          <p:cNvPr id="236" name="Текст"/>
           <p:cNvSpPr txBox="1"/>
           <p:nvPr/>
         </p:nvSpPr>
         <p:spPr>
           <a:xfrm>
-            <a:off x="1417320" y="6986016"/>
-            <a:ext cx="6766560" cy="448056"/>
+            <a:off x="8412480" y="7232903"/>
+            <a:ext cx="3566160" cy="658368"/>
           </a:xfrm>
           <a:prstGeom prst="rect">
             <a:avLst/>
@@ -7496,27 +7341,27 @@
           <a:lstStyle/>
           <a:p>
             <a:r>
-              <a:rPr sz="1600" b="1">
+              <a:rPr sz="1600" b="0">
                 <a:solidFill>
-                  <a:srgbClr val="062D3F"/>
+                  <a:srgbClr val="5E6B73"/>
                 </a:solidFill>
-                <a:latin typeface="Circe Bold"/>
+                <a:latin typeface="Circe"/>
               </a:rPr>
-              <a:t>Валовой городской продукт по видам деятельности</a:t>
+              <a:t>чел.</a:t>
             </a:r>
           </a:p>
         </p:txBody>
       </p:sp>
       <p:sp>
         <p:nvSpPr>
-          <p:cNvPr id="242" name="Текст"/>
+          <p:cNvPr id="237" name="Текст"/>
           <p:cNvSpPr txBox="1"/>
           <p:nvPr/>
         </p:nvSpPr>
         <p:spPr>
           <a:xfrm>
-            <a:off x="8412480" y="6986016"/>
-            <a:ext cx="3566160" cy="448056"/>
+            <a:off x="12252960" y="7232903"/>
+            <a:ext cx="5303520" cy="658368"/>
           </a:xfrm>
           <a:prstGeom prst="rect">
             <a:avLst/>
@@ -7530,60 +7375,26 @@
           <a:lstStyle/>
           <a:p>
             <a:r>
-              <a:rPr sz="1500" b="0">
-                <a:solidFill>
-                  <a:srgbClr val="5E6B73"/>
-                </a:solidFill>
-                <a:latin typeface="Circe"/>
-              </a:rPr>
-              <a:t>млрд руб.</a:t>
-            </a:r>
-          </a:p>
-        </p:txBody>
-      </p:sp>
-      <p:sp>
-        <p:nvSpPr>
-          <p:cNvPr id="243" name="Текст"/>
-          <p:cNvSpPr txBox="1"/>
-          <p:nvPr/>
-        </p:nvSpPr>
-        <p:spPr>
-          <a:xfrm>
-            <a:off x="12252960" y="6986016"/>
-            <a:ext cx="5303520" cy="448056"/>
-          </a:xfrm>
-          <a:prstGeom prst="rect">
-            <a:avLst/>
-          </a:prstGeom>
-          <a:noFill/>
-        </p:spPr>
-        <p:txBody>
-          <a:bodyPr wrap="square" anchor="ctr" lIns="0" rIns="0" tIns="0" bIns="0">
-            <a:spAutoFit/>
-          </a:bodyPr>
-          <a:lstStyle/>
-          <a:p>
-            <a:r>
-              <a:rPr sz="1500" b="0">
+              <a:rPr sz="1600" b="0">
                 <a:solidFill>
                   <a:srgbClr val="062D3F"/>
                 </a:solidFill>
                 <a:latin typeface="Circe"/>
               </a:rPr>
-              <a:t>Значение по каждому виду деятельности</a:t>
+              <a:t>Значение за год и изменение к прогнозу</a:t>
             </a:r>
           </a:p>
         </p:txBody>
       </p:sp>
       <p:cxnSp>
         <p:nvCxnSpPr>
-          <p:cNvPr id="244" name="Разделитель"/>
+          <p:cNvPr id="238" name="Разделитель"/>
           <p:cNvCxnSpPr/>
           <p:nvPr/>
         </p:nvCxnSpPr>
         <p:spPr>
           <a:xfrm>
-            <a:off x="1069848" y="7434072"/>
+            <a:off x="1069848" y="7891271"/>
             <a:ext cx="16870679" cy="0"/>
           </a:xfrm>
           <a:prstGeom prst="line">
@@ -7598,14 +7409,14 @@
       </p:cxnSp>
       <p:sp>
         <p:nvSpPr>
-          <p:cNvPr id="245" name="Текст"/>
+          <p:cNvPr id="239" name="Текст"/>
           <p:cNvSpPr txBox="1"/>
           <p:nvPr/>
         </p:nvSpPr>
         <p:spPr>
           <a:xfrm>
-            <a:off x="1417320" y="7434072"/>
-            <a:ext cx="6766560" cy="448056"/>
+            <a:off x="1417320" y="7891271"/>
+            <a:ext cx="6766560" cy="658368"/>
           </a:xfrm>
           <a:prstGeom prst="rect">
             <a:avLst/>
@@ -7619,27 +7430,27 @@
           <a:lstStyle/>
           <a:p>
             <a:r>
-              <a:rPr sz="1600" b="1">
+              <a:rPr sz="1700" b="1">
                 <a:solidFill>
                   <a:srgbClr val="062D3F"/>
                 </a:solidFill>
                 <a:latin typeface="Circe Bold"/>
               </a:rPr>
-              <a:t>Занятость по видам деятельности</a:t>
+              <a:t>Доходы бюджета</a:t>
             </a:r>
           </a:p>
         </p:txBody>
       </p:sp>
       <p:sp>
         <p:nvSpPr>
-          <p:cNvPr id="246" name="Текст"/>
+          <p:cNvPr id="240" name="Текст"/>
           <p:cNvSpPr txBox="1"/>
           <p:nvPr/>
         </p:nvSpPr>
         <p:spPr>
           <a:xfrm>
-            <a:off x="8412480" y="7434072"/>
-            <a:ext cx="3566160" cy="448056"/>
+            <a:off x="8412480" y="7891271"/>
+            <a:ext cx="3566160" cy="658368"/>
           </a:xfrm>
           <a:prstGeom prst="rect">
             <a:avLst/>
@@ -7653,27 +7464,27 @@
           <a:lstStyle/>
           <a:p>
             <a:r>
-              <a:rPr sz="1500" b="0">
+              <a:rPr sz="1600" b="0">
                 <a:solidFill>
                   <a:srgbClr val="5E6B73"/>
                 </a:solidFill>
                 <a:latin typeface="Circe"/>
               </a:rPr>
-              <a:t>тыс. чел.</a:t>
+              <a:t>млн руб.</a:t>
             </a:r>
           </a:p>
         </p:txBody>
       </p:sp>
       <p:sp>
         <p:nvSpPr>
-          <p:cNvPr id="247" name="Текст"/>
+          <p:cNvPr id="241" name="Текст"/>
           <p:cNvSpPr txBox="1"/>
           <p:nvPr/>
         </p:nvSpPr>
         <p:spPr>
           <a:xfrm>
-            <a:off x="12252960" y="7434072"/>
-            <a:ext cx="5303520" cy="448056"/>
+            <a:off x="12252960" y="7891271"/>
+            <a:ext cx="5303520" cy="658368"/>
           </a:xfrm>
           <a:prstGeom prst="rect">
             <a:avLst/>
@@ -7687,26 +7498,26 @@
           <a:lstStyle/>
           <a:p>
             <a:r>
-              <a:rPr sz="1500" b="0">
+              <a:rPr sz="1600" b="0">
                 <a:solidFill>
                   <a:srgbClr val="062D3F"/>
                 </a:solidFill>
                 <a:latin typeface="Circe"/>
               </a:rPr>
-              <a:t>Значение по каждому виду деятельности</a:t>
+              <a:t>Значение за год и изменение к прогнозу</a:t>
             </a:r>
           </a:p>
         </p:txBody>
       </p:sp>
       <p:cxnSp>
         <p:nvCxnSpPr>
-          <p:cNvPr id="248" name="Разделитель"/>
+          <p:cNvPr id="242" name="Разделитель"/>
           <p:cNvCxnSpPr/>
           <p:nvPr/>
         </p:nvCxnSpPr>
         <p:spPr>
           <a:xfrm>
-            <a:off x="1069848" y="7882128"/>
+            <a:off x="1069848" y="8549640"/>
             <a:ext cx="16870679" cy="0"/>
           </a:xfrm>
           <a:prstGeom prst="line">
@@ -7721,14 +7532,14 @@
       </p:cxnSp>
       <p:sp>
         <p:nvSpPr>
-          <p:cNvPr id="249" name="Текст"/>
+          <p:cNvPr id="243" name="Текст"/>
           <p:cNvSpPr txBox="1"/>
           <p:nvPr/>
         </p:nvSpPr>
         <p:spPr>
           <a:xfrm>
-            <a:off x="1417320" y="7882128"/>
-            <a:ext cx="6766560" cy="448056"/>
+            <a:off x="1417320" y="8549640"/>
+            <a:ext cx="6766560" cy="658368"/>
           </a:xfrm>
           <a:prstGeom prst="rect">
             <a:avLst/>
@@ -7742,27 +7553,27 @@
           <a:lstStyle/>
           <a:p>
             <a:r>
-              <a:rPr sz="1600" b="1">
+              <a:rPr sz="1700" b="1">
                 <a:solidFill>
                   <a:srgbClr val="062D3F"/>
                 </a:solidFill>
                 <a:latin typeface="Circe Bold"/>
               </a:rPr>
-              <a:t>Структура ВГП и структура занятости</a:t>
+              <a:t>Валовая добавленная стоимость</a:t>
             </a:r>
           </a:p>
         </p:txBody>
       </p:sp>
       <p:sp>
         <p:nvSpPr>
-          <p:cNvPr id="250" name="Текст"/>
+          <p:cNvPr id="244" name="Текст"/>
           <p:cNvSpPr txBox="1"/>
           <p:nvPr/>
         </p:nvSpPr>
         <p:spPr>
           <a:xfrm>
-            <a:off x="8412480" y="7882128"/>
-            <a:ext cx="3566160" cy="448056"/>
+            <a:off x="8412480" y="8549640"/>
+            <a:ext cx="3566160" cy="658368"/>
           </a:xfrm>
           <a:prstGeom prst="rect">
             <a:avLst/>
@@ -7776,27 +7587,27 @@
           <a:lstStyle/>
           <a:p>
             <a:r>
-              <a:rPr sz="1500" b="0">
+              <a:rPr sz="1600" b="0">
                 <a:solidFill>
                   <a:srgbClr val="5E6B73"/>
                 </a:solidFill>
                 <a:latin typeface="Circe"/>
               </a:rPr>
-              <a:t>%</a:t>
+              <a:t>млрд руб.</a:t>
             </a:r>
           </a:p>
         </p:txBody>
       </p:sp>
       <p:sp>
         <p:nvSpPr>
-          <p:cNvPr id="251" name="Текст"/>
+          <p:cNvPr id="245" name="Текст"/>
           <p:cNvSpPr txBox="1"/>
           <p:nvPr/>
         </p:nvSpPr>
         <p:spPr>
           <a:xfrm>
-            <a:off x="12252960" y="7882128"/>
-            <a:ext cx="5303520" cy="448056"/>
+            <a:off x="12252960" y="8549640"/>
+            <a:ext cx="5303520" cy="658368"/>
           </a:xfrm>
           <a:prstGeom prst="rect">
             <a:avLst/>
@@ -7810,272 +7621,26 @@
           <a:lstStyle/>
           <a:p>
             <a:r>
-              <a:rPr sz="1500" b="0">
+              <a:rPr sz="1600" b="0">
                 <a:solidFill>
                   <a:srgbClr val="062D3F"/>
                 </a:solidFill>
                 <a:latin typeface="Circe"/>
               </a:rPr>
-              <a:t>Доля вида деятельности в ВГП и в занятости</a:t>
+              <a:t>Значение за год и изменение к прогнозу</a:t>
             </a:r>
           </a:p>
         </p:txBody>
       </p:sp>
       <p:cxnSp>
         <p:nvCxnSpPr>
-          <p:cNvPr id="252" name="Разделитель"/>
+          <p:cNvPr id="246" name="Разделитель"/>
           <p:cNvCxnSpPr/>
           <p:nvPr/>
         </p:nvCxnSpPr>
         <p:spPr>
           <a:xfrm>
-            <a:off x="1069848" y="8330184"/>
-            <a:ext cx="16870679" cy="0"/>
-          </a:xfrm>
-          <a:prstGeom prst="line">
-            <a:avLst/>
-          </a:prstGeom>
-          <a:ln w="12700">
-            <a:solidFill>
-              <a:srgbClr val="D9DEE2"/>
-            </a:solidFill>
-          </a:ln>
-        </p:spPr>
-      </p:cxnSp>
-      <p:sp>
-        <p:nvSpPr>
-          <p:cNvPr id="253" name="Текст"/>
-          <p:cNvSpPr txBox="1"/>
-          <p:nvPr/>
-        </p:nvSpPr>
-        <p:spPr>
-          <a:xfrm>
-            <a:off x="1417320" y="8330184"/>
-            <a:ext cx="6766560" cy="448056"/>
-          </a:xfrm>
-          <a:prstGeom prst="rect">
-            <a:avLst/>
-          </a:prstGeom>
-          <a:noFill/>
-        </p:spPr>
-        <p:txBody>
-          <a:bodyPr wrap="square" anchor="ctr" lIns="0" rIns="0" tIns="0" bIns="0">
-            <a:spAutoFit/>
-          </a:bodyPr>
-          <a:lstStyle/>
-          <a:p>
-            <a:r>
-              <a:rPr sz="1600" b="1">
-                <a:solidFill>
-                  <a:srgbClr val="062D3F"/>
-                </a:solidFill>
-                <a:latin typeface="Circe Bold"/>
-              </a:rPr>
-              <a:t>Производительность труда</a:t>
-            </a:r>
-          </a:p>
-        </p:txBody>
-      </p:sp>
-      <p:sp>
-        <p:nvSpPr>
-          <p:cNvPr id="254" name="Текст"/>
-          <p:cNvSpPr txBox="1"/>
-          <p:nvPr/>
-        </p:nvSpPr>
-        <p:spPr>
-          <a:xfrm>
-            <a:off x="8412480" y="8330184"/>
-            <a:ext cx="3566160" cy="448056"/>
-          </a:xfrm>
-          <a:prstGeom prst="rect">
-            <a:avLst/>
-          </a:prstGeom>
-          <a:noFill/>
-        </p:spPr>
-        <p:txBody>
-          <a:bodyPr wrap="square" anchor="ctr" lIns="0" rIns="0" tIns="0" bIns="0">
-            <a:spAutoFit/>
-          </a:bodyPr>
-          <a:lstStyle/>
-          <a:p>
-            <a:r>
-              <a:rPr sz="1500" b="0">
-                <a:solidFill>
-                  <a:srgbClr val="5E6B73"/>
-                </a:solidFill>
-                <a:latin typeface="Circe"/>
-              </a:rPr>
-              <a:t>млн руб. на 1 занятого</a:t>
-            </a:r>
-          </a:p>
-        </p:txBody>
-      </p:sp>
-      <p:sp>
-        <p:nvSpPr>
-          <p:cNvPr id="255" name="Текст"/>
-          <p:cNvSpPr txBox="1"/>
-          <p:nvPr/>
-        </p:nvSpPr>
-        <p:spPr>
-          <a:xfrm>
-            <a:off x="12252960" y="8330184"/>
-            <a:ext cx="5303520" cy="448056"/>
-          </a:xfrm>
-          <a:prstGeom prst="rect">
-            <a:avLst/>
-          </a:prstGeom>
-          <a:noFill/>
-        </p:spPr>
-        <p:txBody>
-          <a:bodyPr wrap="square" anchor="ctr" lIns="0" rIns="0" tIns="0" bIns="0">
-            <a:spAutoFit/>
-          </a:bodyPr>
-          <a:lstStyle/>
-          <a:p>
-            <a:r>
-              <a:rPr sz="1500" b="0">
-                <a:solidFill>
-                  <a:srgbClr val="062D3F"/>
-                </a:solidFill>
-                <a:latin typeface="Circe"/>
-              </a:rPr>
-              <a:t>ВГП вида деятельности на одного занятого в нём</a:t>
-            </a:r>
-          </a:p>
-        </p:txBody>
-      </p:sp>
-      <p:cxnSp>
-        <p:nvCxnSpPr>
-          <p:cNvPr id="256" name="Разделитель"/>
-          <p:cNvCxnSpPr/>
-          <p:nvPr/>
-        </p:nvCxnSpPr>
-        <p:spPr>
-          <a:xfrm>
-            <a:off x="1069848" y="8778240"/>
-            <a:ext cx="16870679" cy="0"/>
-          </a:xfrm>
-          <a:prstGeom prst="line">
-            <a:avLst/>
-          </a:prstGeom>
-          <a:ln w="12700">
-            <a:solidFill>
-              <a:srgbClr val="D9DEE2"/>
-            </a:solidFill>
-          </a:ln>
-        </p:spPr>
-      </p:cxnSp>
-      <p:sp>
-        <p:nvSpPr>
-          <p:cNvPr id="257" name="Текст"/>
-          <p:cNvSpPr txBox="1"/>
-          <p:nvPr/>
-        </p:nvSpPr>
-        <p:spPr>
-          <a:xfrm>
-            <a:off x="1417320" y="8778240"/>
-            <a:ext cx="6766560" cy="722376"/>
-          </a:xfrm>
-          <a:prstGeom prst="rect">
-            <a:avLst/>
-          </a:prstGeom>
-          <a:noFill/>
-        </p:spPr>
-        <p:txBody>
-          <a:bodyPr wrap="square" anchor="ctr" lIns="0" rIns="0" tIns="0" bIns="0">
-            <a:spAutoFit/>
-          </a:bodyPr>
-          <a:lstStyle/>
-          <a:p>
-            <a:r>
-              <a:rPr sz="1600" b="1">
-                <a:solidFill>
-                  <a:srgbClr val="062D3F"/>
-                </a:solidFill>
-                <a:latin typeface="Circe Bold"/>
-              </a:rPr>
-              <a:t>Численность занятых и населения, доходы бюджета, валовая добавленная стоимость</a:t>
-            </a:r>
-          </a:p>
-        </p:txBody>
-      </p:sp>
-      <p:sp>
-        <p:nvSpPr>
-          <p:cNvPr id="258" name="Текст"/>
-          <p:cNvSpPr txBox="1"/>
-          <p:nvPr/>
-        </p:nvSpPr>
-        <p:spPr>
-          <a:xfrm>
-            <a:off x="8412480" y="8778240"/>
-            <a:ext cx="3566160" cy="722376"/>
-          </a:xfrm>
-          <a:prstGeom prst="rect">
-            <a:avLst/>
-          </a:prstGeom>
-          <a:noFill/>
-        </p:spPr>
-        <p:txBody>
-          <a:bodyPr wrap="square" anchor="ctr" lIns="0" rIns="0" tIns="0" bIns="0">
-            <a:spAutoFit/>
-          </a:bodyPr>
-          <a:lstStyle/>
-          <a:p>
-            <a:r>
-              <a:rPr sz="1500" b="0">
-                <a:solidFill>
-                  <a:srgbClr val="5E6B73"/>
-                </a:solidFill>
-                <a:latin typeface="Circe"/>
-              </a:rPr>
-              <a:t>чел., млн руб., млрд руб.</a:t>
-            </a:r>
-          </a:p>
-        </p:txBody>
-      </p:sp>
-      <p:sp>
-        <p:nvSpPr>
-          <p:cNvPr id="259" name="Текст"/>
-          <p:cNvSpPr txBox="1"/>
-          <p:nvPr/>
-        </p:nvSpPr>
-        <p:spPr>
-          <a:xfrm>
-            <a:off x="12252960" y="8778240"/>
-            <a:ext cx="5303520" cy="722376"/>
-          </a:xfrm>
-          <a:prstGeom prst="rect">
-            <a:avLst/>
-          </a:prstGeom>
-          <a:noFill/>
-        </p:spPr>
-        <p:txBody>
-          <a:bodyPr wrap="square" anchor="ctr" lIns="0" rIns="0" tIns="0" bIns="0">
-            <a:spAutoFit/>
-          </a:bodyPr>
-          <a:lstStyle/>
-          <a:p>
-            <a:r>
-              <a:rPr sz="1500" b="0">
-                <a:solidFill>
-                  <a:srgbClr val="062D3F"/>
-                </a:solidFill>
-                <a:latin typeface="Circe"/>
-              </a:rPr>
-              <a:t>Итоговые показатели территории и их изменение к 2035 году</a:t>
-            </a:r>
-          </a:p>
-        </p:txBody>
-      </p:sp>
-      <p:cxnSp>
-        <p:nvCxnSpPr>
-          <p:cNvPr id="260" name="Разделитель"/>
-          <p:cNvCxnSpPr/>
-          <p:nvPr/>
-        </p:nvCxnSpPr>
-        <p:spPr>
-          <a:xfrm>
-            <a:off x="1069848" y="9500616"/>
+            <a:off x="1069848" y="9208008"/>
             <a:ext cx="16870679" cy="0"/>
           </a:xfrm>
           <a:prstGeom prst="line">

</xml_diff>

<commit_message>
Economy structure indicators slide in the same style with data sources
Co-Authored-By: Claude Sonnet 5.5 <noreply@anthropic.com>
Claude-Session: https://claude.ai/code/session_01PfagTkBBfn3ShTm5bX9M45
</commit_message>
<xml_diff>
--- a/slide_pokazateli_struktura_ekonomiki.pptx
+++ b/slide_pokazateli_struktura_ekonomiki.pptx
@@ -430,7 +430,7 @@
           <a:lstStyle/>
           <a:p>
             <a:r>
-              <a:t>Единый перечень составлен по содержимому слайдов 25 и 26 презентации (Севастополь, Ноябрьск), без привязки к конкретным слайдам. Колонка источников данных не добавлена: в презентации они для этих слайдов не указаны, их нужно добавить после сверки (для Севастополя ВРП и занятость по видам деятельности обычно берутся из статистики Росстата).</a:t>
+              <a:t>Единый перечень составлен по содержимому слайдов про структуру экономики (занятость, ВРП, производительность труда) и анализ экономики города. Колонка источников написана по общим сведениям о публикации данных (ЕМИСС, БД ПМО, Росстат по региону, отчёты об исполнении бюджета), названия таблиц и доступность данных по муниципалитетам нужно сверить. ВРП и добавленная стоимость официально публикуются по региону, для района или города их оценивают расчётом.</a:t>
             </a:r>
           </a:p>
         </p:txBody>
@@ -6302,14 +6302,45 @@
       </p:sp>
       <p:sp>
         <p:nvSpPr>
-          <p:cNvPr id="203" name="Заголовок колонки"/>
+          <p:cNvPr id="203" name="Шапка таблицы"/>
+          <p:cNvSpPr/>
+          <p:nvPr/>
+        </p:nvSpPr>
+        <p:spPr>
+          <a:xfrm>
+            <a:off x="1069848" y="2057400"/>
+            <a:ext cx="16870680" cy="502920"/>
+          </a:xfrm>
+          <a:prstGeom prst="roundRect">
+            <a:avLst>
+              <a:gd name="adj" fmla="val 25000"/>
+            </a:avLst>
+          </a:prstGeom>
+          <a:solidFill>
+            <a:srgbClr val="062D3F"/>
+          </a:solidFill>
+          <a:ln>
+            <a:noFill/>
+          </a:ln>
+        </p:spPr>
+        <p:txBody>
+          <a:bodyPr rtlCol="0" anchor="ctr"/>
+          <a:lstStyle/>
+          <a:p>
+            <a:pPr algn="ctr"/>
+          </a:p>
+        </p:txBody>
+      </p:sp>
+      <p:sp>
+        <p:nvSpPr>
+          <p:cNvPr id="204" name="Заголовок колонки"/>
           <p:cNvSpPr txBox="1"/>
           <p:nvPr/>
         </p:nvSpPr>
         <p:spPr>
           <a:xfrm>
-            <a:off x="1417320" y="2057400"/>
-            <a:ext cx="6766560" cy="365760"/>
+            <a:off x="2011680" y="2057400"/>
+            <a:ext cx="5029200" cy="502920"/>
           </a:xfrm>
           <a:prstGeom prst="rect">
             <a:avLst/>
@@ -6324,26 +6355,197 @@
           <a:p>
             <a:r>
               <a:rPr sz="1600" b="1">
+                <a:solidFill>
+                  <a:srgbClr val="FFFFFF"/>
+                </a:solidFill>
+                <a:latin typeface="Circe Bold"/>
+              </a:rPr>
+              <a:t>ПОКАЗАТЕЛЬ</a:t>
+            </a:r>
+          </a:p>
+        </p:txBody>
+      </p:sp>
+      <p:sp>
+        <p:nvSpPr>
+          <p:cNvPr id="205" name="Заголовок колонки"/>
+          <p:cNvSpPr txBox="1"/>
+          <p:nvPr/>
+        </p:nvSpPr>
+        <p:spPr>
+          <a:xfrm>
+            <a:off x="7178040" y="2057400"/>
+            <a:ext cx="2743200" cy="502920"/>
+          </a:xfrm>
+          <a:prstGeom prst="rect">
+            <a:avLst/>
+          </a:prstGeom>
+          <a:noFill/>
+        </p:spPr>
+        <p:txBody>
+          <a:bodyPr wrap="square" anchor="ctr" lIns="0" rIns="0" tIns="0" bIns="0">
+            <a:spAutoFit/>
+          </a:bodyPr>
+          <a:lstStyle/>
+          <a:p>
+            <a:r>
+              <a:rPr sz="1600" b="1">
+                <a:solidFill>
+                  <a:srgbClr val="FFFFFF"/>
+                </a:solidFill>
+                <a:latin typeface="Circe Bold"/>
+              </a:rPr>
+              <a:t>ЕДИНИЦА</a:t>
+            </a:r>
+          </a:p>
+        </p:txBody>
+      </p:sp>
+      <p:sp>
+        <p:nvSpPr>
+          <p:cNvPr id="206" name="Заголовок колонки"/>
+          <p:cNvSpPr txBox="1"/>
+          <p:nvPr/>
+        </p:nvSpPr>
+        <p:spPr>
+          <a:xfrm>
+            <a:off x="10058400" y="2057400"/>
+            <a:ext cx="3657600" cy="502920"/>
+          </a:xfrm>
+          <a:prstGeom prst="rect">
+            <a:avLst/>
+          </a:prstGeom>
+          <a:noFill/>
+        </p:spPr>
+        <p:txBody>
+          <a:bodyPr wrap="square" anchor="ctr" lIns="0" rIns="0" tIns="0" bIns="0">
+            <a:spAutoFit/>
+          </a:bodyPr>
+          <a:lstStyle/>
+          <a:p>
+            <a:r>
+              <a:rPr sz="1600" b="1">
+                <a:solidFill>
+                  <a:srgbClr val="FFFFFF"/>
+                </a:solidFill>
+                <a:latin typeface="Circe Bold"/>
+              </a:rPr>
+              <a:t>ЧТО ПОКАЗЫВАЕТ</a:t>
+            </a:r>
+          </a:p>
+        </p:txBody>
+      </p:sp>
+      <p:sp>
+        <p:nvSpPr>
+          <p:cNvPr id="207" name="Заголовок колонки"/>
+          <p:cNvSpPr txBox="1"/>
+          <p:nvPr/>
+        </p:nvSpPr>
+        <p:spPr>
+          <a:xfrm>
+            <a:off x="13853160" y="2057400"/>
+            <a:ext cx="4023360" cy="502920"/>
+          </a:xfrm>
+          <a:prstGeom prst="rect">
+            <a:avLst/>
+          </a:prstGeom>
+          <a:noFill/>
+        </p:spPr>
+        <p:txBody>
+          <a:bodyPr wrap="square" anchor="ctr" lIns="0" rIns="0" tIns="0" bIns="0">
+            <a:spAutoFit/>
+          </a:bodyPr>
+          <a:lstStyle/>
+          <a:p>
+            <a:r>
+              <a:rPr sz="1600" b="1">
+                <a:solidFill>
+                  <a:srgbClr val="FFFFFF"/>
+                </a:solidFill>
+                <a:latin typeface="Circe Bold"/>
+              </a:rPr>
+              <a:t>ИСТОЧНИК ДАННЫХ</a:t>
+            </a:r>
+          </a:p>
+        </p:txBody>
+      </p:sp>
+      <p:sp>
+        <p:nvSpPr>
+          <p:cNvPr id="208" name="Полоса"/>
+          <p:cNvSpPr/>
+          <p:nvPr/>
+        </p:nvSpPr>
+        <p:spPr>
+          <a:xfrm>
+            <a:off x="1069848" y="2706624"/>
+            <a:ext cx="16870680" cy="621792"/>
+          </a:xfrm>
+          <a:prstGeom prst="roundRect">
+            <a:avLst>
+              <a:gd name="adj" fmla="val 30000"/>
+            </a:avLst>
+          </a:prstGeom>
+          <a:solidFill>
+            <a:srgbClr val="FFF3CC"/>
+          </a:solidFill>
+          <a:ln>
+            <a:noFill/>
+          </a:ln>
+        </p:spPr>
+        <p:txBody>
+          <a:bodyPr rtlCol="0" anchor="ctr"/>
+          <a:lstStyle/>
+          <a:p>
+            <a:pPr algn="ctr"/>
+          </a:p>
+        </p:txBody>
+      </p:sp>
+      <p:sp>
+        <p:nvSpPr>
+          <p:cNvPr id="209" name="Номер 1"/>
+          <p:cNvSpPr/>
+          <p:nvPr/>
+        </p:nvSpPr>
+        <p:spPr>
+          <a:xfrm>
+            <a:off x="1417320" y="2816352"/>
+            <a:ext cx="402336" cy="402336"/>
+          </a:xfrm>
+          <a:prstGeom prst="ellipse">
+            <a:avLst/>
+          </a:prstGeom>
+          <a:solidFill>
+            <a:srgbClr val="FFCC00"/>
+          </a:solidFill>
+          <a:ln>
+            <a:noFill/>
+          </a:ln>
+        </p:spPr>
+        <p:txBody>
+          <a:bodyPr rtlCol="0" anchor="ctr" lIns="0" rIns="0" tIns="0" bIns="0"/>
+          <a:lstStyle/>
+          <a:p>
+            <a:pPr algn="ctr"/>
+            <a:r>
+              <a:rPr sz="1500" b="1">
                 <a:solidFill>
                   <a:srgbClr val="062D3F"/>
                 </a:solidFill>
                 <a:latin typeface="Circe Bold"/>
               </a:rPr>
-              <a:t>ПОКАЗАТЕЛЬ</a:t>
+              <a:t>1</a:t>
             </a:r>
           </a:p>
         </p:txBody>
       </p:sp>
       <p:sp>
         <p:nvSpPr>
-          <p:cNvPr id="204" name="Заголовок колонки"/>
+          <p:cNvPr id="210" name="Текст"/>
           <p:cNvSpPr txBox="1"/>
           <p:nvPr/>
         </p:nvSpPr>
         <p:spPr>
           <a:xfrm>
-            <a:off x="8412480" y="2057400"/>
-            <a:ext cx="3566160" cy="365760"/>
+            <a:off x="2011680" y="2679192"/>
+            <a:ext cx="5029200" cy="676656"/>
           </a:xfrm>
           <a:prstGeom prst="rect">
             <a:avLst/>
@@ -6357,96 +6559,7 @@
           <a:lstStyle/>
           <a:p>
             <a:r>
-              <a:rPr sz="1600" b="1">
-                <a:solidFill>
-                  <a:srgbClr val="062D3F"/>
-                </a:solidFill>
-                <a:latin typeface="Circe Bold"/>
-              </a:rPr>
-              <a:t>ЕДИНИЦА</a:t>
-            </a:r>
-          </a:p>
-        </p:txBody>
-      </p:sp>
-      <p:sp>
-        <p:nvSpPr>
-          <p:cNvPr id="205" name="Заголовок колонки"/>
-          <p:cNvSpPr txBox="1"/>
-          <p:nvPr/>
-        </p:nvSpPr>
-        <p:spPr>
-          <a:xfrm>
-            <a:off x="12252960" y="2057400"/>
-            <a:ext cx="5303520" cy="365760"/>
-          </a:xfrm>
-          <a:prstGeom prst="rect">
-            <a:avLst/>
-          </a:prstGeom>
-          <a:noFill/>
-        </p:spPr>
-        <p:txBody>
-          <a:bodyPr wrap="square" anchor="ctr" lIns="0" rIns="0" tIns="0" bIns="0">
-            <a:spAutoFit/>
-          </a:bodyPr>
-          <a:lstStyle/>
-          <a:p>
-            <a:r>
-              <a:rPr sz="1600" b="1">
-                <a:solidFill>
-                  <a:srgbClr val="062D3F"/>
-                </a:solidFill>
-                <a:latin typeface="Circe Bold"/>
-              </a:rPr>
-              <a:t>ЧТО ПОКАЗЫВАЕТ</a:t>
-            </a:r>
-          </a:p>
-        </p:txBody>
-      </p:sp>
-      <p:cxnSp>
-        <p:nvCxnSpPr>
-          <p:cNvPr id="206" name="Линия заголовка"/>
-          <p:cNvCxnSpPr/>
-          <p:nvPr/>
-        </p:nvCxnSpPr>
-        <p:spPr>
-          <a:xfrm>
-            <a:off x="1069848" y="2514600"/>
-            <a:ext cx="16870679" cy="0"/>
-          </a:xfrm>
-          <a:prstGeom prst="line">
-            <a:avLst/>
-          </a:prstGeom>
-          <a:ln w="19050">
-            <a:solidFill>
-              <a:srgbClr val="062D3F"/>
-            </a:solidFill>
-          </a:ln>
-        </p:spPr>
-      </p:cxnSp>
-      <p:sp>
-        <p:nvSpPr>
-          <p:cNvPr id="207" name="Текст"/>
-          <p:cNvSpPr txBox="1"/>
-          <p:nvPr/>
-        </p:nvSpPr>
-        <p:spPr>
-          <a:xfrm>
-            <a:off x="1417320" y="2624328"/>
-            <a:ext cx="6766560" cy="658368"/>
-          </a:xfrm>
-          <a:prstGeom prst="rect">
-            <a:avLst/>
-          </a:prstGeom>
-          <a:noFill/>
-        </p:spPr>
-        <p:txBody>
-          <a:bodyPr wrap="square" anchor="ctr" lIns="0" rIns="0" tIns="0" bIns="0">
-            <a:spAutoFit/>
-          </a:bodyPr>
-          <a:lstStyle/>
-          <a:p>
-            <a:r>
-              <a:rPr sz="1700" b="1">
+              <a:rPr sz="1500" b="1">
                 <a:solidFill>
                   <a:srgbClr val="062D3F"/>
                 </a:solidFill>
@@ -6459,14 +6572,14 @@
       </p:sp>
       <p:sp>
         <p:nvSpPr>
-          <p:cNvPr id="208" name="Текст"/>
+          <p:cNvPr id="211" name="Текст"/>
           <p:cNvSpPr txBox="1"/>
           <p:nvPr/>
         </p:nvSpPr>
         <p:spPr>
           <a:xfrm>
-            <a:off x="8412480" y="2624328"/>
-            <a:ext cx="3566160" cy="658368"/>
+            <a:off x="7178040" y="2679192"/>
+            <a:ext cx="2743200" cy="676656"/>
           </a:xfrm>
           <a:prstGeom prst="rect">
             <a:avLst/>
@@ -6480,9 +6593,9 @@
           <a:lstStyle/>
           <a:p>
             <a:r>
-              <a:rPr sz="1600" b="0">
+              <a:rPr sz="1400" b="0">
                 <a:solidFill>
-                  <a:srgbClr val="5E6B73"/>
+                  <a:srgbClr val="062D3F"/>
                 </a:solidFill>
                 <a:latin typeface="Circe"/>
               </a:rPr>
@@ -6493,14 +6606,14 @@
       </p:sp>
       <p:sp>
         <p:nvSpPr>
-          <p:cNvPr id="209" name="Текст"/>
+          <p:cNvPr id="212" name="Текст"/>
           <p:cNvSpPr txBox="1"/>
           <p:nvPr/>
         </p:nvSpPr>
         <p:spPr>
           <a:xfrm>
-            <a:off x="12252960" y="2624328"/>
-            <a:ext cx="5303520" cy="658368"/>
+            <a:off x="10058400" y="2679192"/>
+            <a:ext cx="3657600" cy="676656"/>
           </a:xfrm>
           <a:prstGeom prst="rect">
             <a:avLst/>
@@ -6514,7 +6627,7 @@
           <a:lstStyle/>
           <a:p>
             <a:r>
-              <a:rPr sz="1600" b="0">
+              <a:rPr sz="1400" b="0">
                 <a:solidFill>
                   <a:srgbClr val="062D3F"/>
                 </a:solidFill>
@@ -6525,37 +6638,16 @@
           </a:p>
         </p:txBody>
       </p:sp>
-      <p:cxnSp>
-        <p:nvCxnSpPr>
-          <p:cNvPr id="210" name="Разделитель"/>
-          <p:cNvCxnSpPr/>
-          <p:nvPr/>
-        </p:nvCxnSpPr>
-        <p:spPr>
-          <a:xfrm>
-            <a:off x="1069848" y="3282696"/>
-            <a:ext cx="16870679" cy="0"/>
-          </a:xfrm>
-          <a:prstGeom prst="line">
-            <a:avLst/>
-          </a:prstGeom>
-          <a:ln w="12700">
-            <a:solidFill>
-              <a:srgbClr val="D9DEE2"/>
-            </a:solidFill>
-          </a:ln>
-        </p:spPr>
-      </p:cxnSp>
-      <p:sp>
-        <p:nvSpPr>
-          <p:cNvPr id="211" name="Текст"/>
+      <p:sp>
+        <p:nvSpPr>
+          <p:cNvPr id="213" name="Текст"/>
           <p:cNvSpPr txBox="1"/>
           <p:nvPr/>
         </p:nvSpPr>
         <p:spPr>
           <a:xfrm>
-            <a:off x="1417320" y="3282696"/>
-            <a:ext cx="6766560" cy="658368"/>
+            <a:off x="13853160" y="2679192"/>
+            <a:ext cx="4023360" cy="676656"/>
           </a:xfrm>
           <a:prstGeom prst="rect">
             <a:avLst/>
@@ -6569,7 +6661,79 @@
           <a:lstStyle/>
           <a:p>
             <a:r>
-              <a:rPr sz="1700" b="1">
+              <a:rPr sz="1400" b="0">
+                <a:solidFill>
+                  <a:srgbClr val="062D3F"/>
+                </a:solidFill>
+                <a:latin typeface="Circe"/>
+              </a:rPr>
+              <a:t>ЕМИСС, БД ПМО</a:t>
+            </a:r>
+          </a:p>
+        </p:txBody>
+      </p:sp>
+      <p:sp>
+        <p:nvSpPr>
+          <p:cNvPr id="214" name="Номер 2"/>
+          <p:cNvSpPr/>
+          <p:nvPr/>
+        </p:nvSpPr>
+        <p:spPr>
+          <a:xfrm>
+            <a:off x="1417320" y="3493008"/>
+            <a:ext cx="402336" cy="402336"/>
+          </a:xfrm>
+          <a:prstGeom prst="ellipse">
+            <a:avLst/>
+          </a:prstGeom>
+          <a:solidFill>
+            <a:srgbClr val="FFCC00"/>
+          </a:solidFill>
+          <a:ln>
+            <a:noFill/>
+          </a:ln>
+        </p:spPr>
+        <p:txBody>
+          <a:bodyPr rtlCol="0" anchor="ctr" lIns="0" rIns="0" tIns="0" bIns="0"/>
+          <a:lstStyle/>
+          <a:p>
+            <a:pPr algn="ctr"/>
+            <a:r>
+              <a:rPr sz="1500" b="1">
+                <a:solidFill>
+                  <a:srgbClr val="062D3F"/>
+                </a:solidFill>
+                <a:latin typeface="Circe Bold"/>
+              </a:rPr>
+              <a:t>2</a:t>
+            </a:r>
+          </a:p>
+        </p:txBody>
+      </p:sp>
+      <p:sp>
+        <p:nvSpPr>
+          <p:cNvPr id="215" name="Текст"/>
+          <p:cNvSpPr txBox="1"/>
+          <p:nvPr/>
+        </p:nvSpPr>
+        <p:spPr>
+          <a:xfrm>
+            <a:off x="2011680" y="3355848"/>
+            <a:ext cx="5029200" cy="676656"/>
+          </a:xfrm>
+          <a:prstGeom prst="rect">
+            <a:avLst/>
+          </a:prstGeom>
+          <a:noFill/>
+        </p:spPr>
+        <p:txBody>
+          <a:bodyPr wrap="square" anchor="ctr" lIns="0" rIns="0" tIns="0" bIns="0">
+            <a:spAutoFit/>
+          </a:bodyPr>
+          <a:lstStyle/>
+          <a:p>
+            <a:r>
+              <a:rPr sz="1500" b="1">
                 <a:solidFill>
                   <a:srgbClr val="062D3F"/>
                 </a:solidFill>
@@ -6582,14 +6746,14 @@
       </p:sp>
       <p:sp>
         <p:nvSpPr>
-          <p:cNvPr id="212" name="Текст"/>
+          <p:cNvPr id="216" name="Текст"/>
           <p:cNvSpPr txBox="1"/>
           <p:nvPr/>
         </p:nvSpPr>
         <p:spPr>
           <a:xfrm>
-            <a:off x="8412480" y="3282696"/>
-            <a:ext cx="3566160" cy="658368"/>
+            <a:off x="7178040" y="3355848"/>
+            <a:ext cx="2743200" cy="676656"/>
           </a:xfrm>
           <a:prstGeom prst="rect">
             <a:avLst/>
@@ -6603,9 +6767,9 @@
           <a:lstStyle/>
           <a:p>
             <a:r>
-              <a:rPr sz="1600" b="0">
+              <a:rPr sz="1400" b="0">
                 <a:solidFill>
-                  <a:srgbClr val="5E6B73"/>
+                  <a:srgbClr val="062D3F"/>
                 </a:solidFill>
                 <a:latin typeface="Circe"/>
               </a:rPr>
@@ -6616,14 +6780,14 @@
       </p:sp>
       <p:sp>
         <p:nvSpPr>
-          <p:cNvPr id="213" name="Текст"/>
+          <p:cNvPr id="217" name="Текст"/>
           <p:cNvSpPr txBox="1"/>
           <p:nvPr/>
         </p:nvSpPr>
         <p:spPr>
           <a:xfrm>
-            <a:off x="12252960" y="3282696"/>
-            <a:ext cx="5303520" cy="658368"/>
+            <a:off x="10058400" y="3355848"/>
+            <a:ext cx="3657600" cy="676656"/>
           </a:xfrm>
           <a:prstGeom prst="rect">
             <a:avLst/>
@@ -6637,7 +6801,7 @@
           <a:lstStyle/>
           <a:p>
             <a:r>
-              <a:rPr sz="1600" b="0">
+              <a:rPr sz="1400" b="0">
                 <a:solidFill>
                   <a:srgbClr val="062D3F"/>
                 </a:solidFill>
@@ -6648,37 +6812,16 @@
           </a:p>
         </p:txBody>
       </p:sp>
-      <p:cxnSp>
-        <p:nvCxnSpPr>
-          <p:cNvPr id="214" name="Разделитель"/>
-          <p:cNvCxnSpPr/>
-          <p:nvPr/>
-        </p:nvCxnSpPr>
-        <p:spPr>
-          <a:xfrm>
-            <a:off x="1069848" y="3941063"/>
-            <a:ext cx="16870679" cy="0"/>
-          </a:xfrm>
-          <a:prstGeom prst="line">
-            <a:avLst/>
-          </a:prstGeom>
-          <a:ln w="12700">
-            <a:solidFill>
-              <a:srgbClr val="D9DEE2"/>
-            </a:solidFill>
-          </a:ln>
-        </p:spPr>
-      </p:cxnSp>
-      <p:sp>
-        <p:nvSpPr>
-          <p:cNvPr id="215" name="Текст"/>
+      <p:sp>
+        <p:nvSpPr>
+          <p:cNvPr id="218" name="Текст"/>
           <p:cNvSpPr txBox="1"/>
           <p:nvPr/>
         </p:nvSpPr>
         <p:spPr>
           <a:xfrm>
-            <a:off x="1417320" y="3941063"/>
-            <a:ext cx="6766560" cy="658368"/>
+            <a:off x="13853160" y="3355848"/>
+            <a:ext cx="4023360" cy="676656"/>
           </a:xfrm>
           <a:prstGeom prst="rect">
             <a:avLst/>
@@ -6692,7 +6835,110 @@
           <a:lstStyle/>
           <a:p>
             <a:r>
-              <a:rPr sz="1700" b="1">
+              <a:rPr sz="1400" b="0">
+                <a:solidFill>
+                  <a:srgbClr val="062D3F"/>
+                </a:solidFill>
+                <a:latin typeface="Circe"/>
+              </a:rPr>
+              <a:t>Росстат по региону, расчёт по муниципалитету</a:t>
+            </a:r>
+          </a:p>
+        </p:txBody>
+      </p:sp>
+      <p:sp>
+        <p:nvSpPr>
+          <p:cNvPr id="219" name="Полоса"/>
+          <p:cNvSpPr/>
+          <p:nvPr/>
+        </p:nvSpPr>
+        <p:spPr>
+          <a:xfrm>
+            <a:off x="1069848" y="4059936"/>
+            <a:ext cx="16870680" cy="621792"/>
+          </a:xfrm>
+          <a:prstGeom prst="roundRect">
+            <a:avLst>
+              <a:gd name="adj" fmla="val 30000"/>
+            </a:avLst>
+          </a:prstGeom>
+          <a:solidFill>
+            <a:srgbClr val="FFF3CC"/>
+          </a:solidFill>
+          <a:ln>
+            <a:noFill/>
+          </a:ln>
+        </p:spPr>
+        <p:txBody>
+          <a:bodyPr rtlCol="0" anchor="ctr"/>
+          <a:lstStyle/>
+          <a:p>
+            <a:pPr algn="ctr"/>
+          </a:p>
+        </p:txBody>
+      </p:sp>
+      <p:sp>
+        <p:nvSpPr>
+          <p:cNvPr id="220" name="Номер 3"/>
+          <p:cNvSpPr/>
+          <p:nvPr/>
+        </p:nvSpPr>
+        <p:spPr>
+          <a:xfrm>
+            <a:off x="1417320" y="4169664"/>
+            <a:ext cx="402336" cy="402336"/>
+          </a:xfrm>
+          <a:prstGeom prst="ellipse">
+            <a:avLst/>
+          </a:prstGeom>
+          <a:solidFill>
+            <a:srgbClr val="FFCC00"/>
+          </a:solidFill>
+          <a:ln>
+            <a:noFill/>
+          </a:ln>
+        </p:spPr>
+        <p:txBody>
+          <a:bodyPr rtlCol="0" anchor="ctr" lIns="0" rIns="0" tIns="0" bIns="0"/>
+          <a:lstStyle/>
+          <a:p>
+            <a:pPr algn="ctr"/>
+            <a:r>
+              <a:rPr sz="1500" b="1">
+                <a:solidFill>
+                  <a:srgbClr val="062D3F"/>
+                </a:solidFill>
+                <a:latin typeface="Circe Bold"/>
+              </a:rPr>
+              <a:t>3</a:t>
+            </a:r>
+          </a:p>
+        </p:txBody>
+      </p:sp>
+      <p:sp>
+        <p:nvSpPr>
+          <p:cNvPr id="221" name="Текст"/>
+          <p:cNvSpPr txBox="1"/>
+          <p:nvPr/>
+        </p:nvSpPr>
+        <p:spPr>
+          <a:xfrm>
+            <a:off x="2011680" y="4032504"/>
+            <a:ext cx="5029200" cy="676656"/>
+          </a:xfrm>
+          <a:prstGeom prst="rect">
+            <a:avLst/>
+          </a:prstGeom>
+          <a:noFill/>
+        </p:spPr>
+        <p:txBody>
+          <a:bodyPr wrap="square" anchor="ctr" lIns="0" rIns="0" tIns="0" bIns="0">
+            <a:spAutoFit/>
+          </a:bodyPr>
+          <a:lstStyle/>
+          <a:p>
+            <a:r>
+              <a:rPr sz="1500" b="1">
                 <a:solidFill>
                   <a:srgbClr val="062D3F"/>
                 </a:solidFill>
@@ -6705,14 +6951,14 @@
       </p:sp>
       <p:sp>
         <p:nvSpPr>
-          <p:cNvPr id="216" name="Текст"/>
+          <p:cNvPr id="222" name="Текст"/>
           <p:cNvSpPr txBox="1"/>
           <p:nvPr/>
         </p:nvSpPr>
         <p:spPr>
           <a:xfrm>
-            <a:off x="8412480" y="3941063"/>
-            <a:ext cx="3566160" cy="658368"/>
+            <a:off x="7178040" y="4032504"/>
+            <a:ext cx="2743200" cy="676656"/>
           </a:xfrm>
           <a:prstGeom prst="rect">
             <a:avLst/>
@@ -6726,9 +6972,9 @@
           <a:lstStyle/>
           <a:p>
             <a:r>
-              <a:rPr sz="1600" b="0">
+              <a:rPr sz="1400" b="0">
                 <a:solidFill>
-                  <a:srgbClr val="5E6B73"/>
+                  <a:srgbClr val="062D3F"/>
                 </a:solidFill>
                 <a:latin typeface="Circe"/>
               </a:rPr>
@@ -6739,14 +6985,14 @@
       </p:sp>
       <p:sp>
         <p:nvSpPr>
-          <p:cNvPr id="217" name="Текст"/>
+          <p:cNvPr id="223" name="Текст"/>
           <p:cNvSpPr txBox="1"/>
           <p:nvPr/>
         </p:nvSpPr>
         <p:spPr>
           <a:xfrm>
-            <a:off x="12252960" y="3941063"/>
-            <a:ext cx="5303520" cy="658368"/>
+            <a:off x="10058400" y="4032504"/>
+            <a:ext cx="3657600" cy="676656"/>
           </a:xfrm>
           <a:prstGeom prst="rect">
             <a:avLst/>
@@ -6760,7 +7006,7 @@
           <a:lstStyle/>
           <a:p>
             <a:r>
-              <a:rPr sz="1600" b="0">
+              <a:rPr sz="1400" b="0">
                 <a:solidFill>
                   <a:srgbClr val="062D3F"/>
                 </a:solidFill>
@@ -6771,37 +7017,16 @@
           </a:p>
         </p:txBody>
       </p:sp>
-      <p:cxnSp>
-        <p:nvCxnSpPr>
-          <p:cNvPr id="218" name="Разделитель"/>
-          <p:cNvCxnSpPr/>
-          <p:nvPr/>
-        </p:nvCxnSpPr>
-        <p:spPr>
-          <a:xfrm>
-            <a:off x="1069848" y="4599431"/>
-            <a:ext cx="16870679" cy="0"/>
-          </a:xfrm>
-          <a:prstGeom prst="line">
-            <a:avLst/>
-          </a:prstGeom>
-          <a:ln w="12700">
-            <a:solidFill>
-              <a:srgbClr val="D9DEE2"/>
-            </a:solidFill>
-          </a:ln>
-        </p:spPr>
-      </p:cxnSp>
-      <p:sp>
-        <p:nvSpPr>
-          <p:cNvPr id="219" name="Текст"/>
+      <p:sp>
+        <p:nvSpPr>
+          <p:cNvPr id="224" name="Текст"/>
           <p:cNvSpPr txBox="1"/>
           <p:nvPr/>
         </p:nvSpPr>
         <p:spPr>
           <a:xfrm>
-            <a:off x="1417320" y="4599431"/>
-            <a:ext cx="6766560" cy="658368"/>
+            <a:off x="13853160" y="4032504"/>
+            <a:ext cx="4023360" cy="676656"/>
           </a:xfrm>
           <a:prstGeom prst="rect">
             <a:avLst/>
@@ -6815,7 +7040,79 @@
           <a:lstStyle/>
           <a:p>
             <a:r>
-              <a:rPr sz="1700" b="1">
+              <a:rPr sz="1400" b="0">
+                <a:solidFill>
+                  <a:srgbClr val="062D3F"/>
+                </a:solidFill>
+                <a:latin typeface="Circe"/>
+              </a:rPr>
+              <a:t>Расчёт по продукту и занятости</a:t>
+            </a:r>
+          </a:p>
+        </p:txBody>
+      </p:sp>
+      <p:sp>
+        <p:nvSpPr>
+          <p:cNvPr id="225" name="Номер 4"/>
+          <p:cNvSpPr/>
+          <p:nvPr/>
+        </p:nvSpPr>
+        <p:spPr>
+          <a:xfrm>
+            <a:off x="1417320" y="4846320"/>
+            <a:ext cx="402336" cy="402336"/>
+          </a:xfrm>
+          <a:prstGeom prst="ellipse">
+            <a:avLst/>
+          </a:prstGeom>
+          <a:solidFill>
+            <a:srgbClr val="FFCC00"/>
+          </a:solidFill>
+          <a:ln>
+            <a:noFill/>
+          </a:ln>
+        </p:spPr>
+        <p:txBody>
+          <a:bodyPr rtlCol="0" anchor="ctr" lIns="0" rIns="0" tIns="0" bIns="0"/>
+          <a:lstStyle/>
+          <a:p>
+            <a:pPr algn="ctr"/>
+            <a:r>
+              <a:rPr sz="1500" b="1">
+                <a:solidFill>
+                  <a:srgbClr val="062D3F"/>
+                </a:solidFill>
+                <a:latin typeface="Circe Bold"/>
+              </a:rPr>
+              <a:t>4</a:t>
+            </a:r>
+          </a:p>
+        </p:txBody>
+      </p:sp>
+      <p:sp>
+        <p:nvSpPr>
+          <p:cNvPr id="226" name="Текст"/>
+          <p:cNvSpPr txBox="1"/>
+          <p:nvPr/>
+        </p:nvSpPr>
+        <p:spPr>
+          <a:xfrm>
+            <a:off x="2011680" y="4709160"/>
+            <a:ext cx="5029200" cy="676656"/>
+          </a:xfrm>
+          <a:prstGeom prst="rect">
+            <a:avLst/>
+          </a:prstGeom>
+          <a:noFill/>
+        </p:spPr>
+        <p:txBody>
+          <a:bodyPr wrap="square" anchor="ctr" lIns="0" rIns="0" tIns="0" bIns="0">
+            <a:spAutoFit/>
+          </a:bodyPr>
+          <a:lstStyle/>
+          <a:p>
+            <a:r>
+              <a:rPr sz="1500" b="1">
                 <a:solidFill>
                   <a:srgbClr val="062D3F"/>
                 </a:solidFill>
@@ -6828,14 +7125,14 @@
       </p:sp>
       <p:sp>
         <p:nvSpPr>
-          <p:cNvPr id="220" name="Текст"/>
+          <p:cNvPr id="227" name="Текст"/>
           <p:cNvSpPr txBox="1"/>
           <p:nvPr/>
         </p:nvSpPr>
         <p:spPr>
           <a:xfrm>
-            <a:off x="8412480" y="4599431"/>
-            <a:ext cx="3566160" cy="658368"/>
+            <a:off x="7178040" y="4709160"/>
+            <a:ext cx="2743200" cy="676656"/>
           </a:xfrm>
           <a:prstGeom prst="rect">
             <a:avLst/>
@@ -6849,9 +7146,9 @@
           <a:lstStyle/>
           <a:p>
             <a:r>
-              <a:rPr sz="1600" b="0">
+              <a:rPr sz="1400" b="0">
                 <a:solidFill>
-                  <a:srgbClr val="5E6B73"/>
+                  <a:srgbClr val="062D3F"/>
                 </a:solidFill>
                 <a:latin typeface="Circe"/>
               </a:rPr>
@@ -6862,14 +7159,14 @@
       </p:sp>
       <p:sp>
         <p:nvSpPr>
-          <p:cNvPr id="221" name="Текст"/>
+          <p:cNvPr id="228" name="Текст"/>
           <p:cNvSpPr txBox="1"/>
           <p:nvPr/>
         </p:nvSpPr>
         <p:spPr>
           <a:xfrm>
-            <a:off x="12252960" y="4599431"/>
-            <a:ext cx="5303520" cy="658368"/>
+            <a:off x="10058400" y="4709160"/>
+            <a:ext cx="3657600" cy="676656"/>
           </a:xfrm>
           <a:prstGeom prst="rect">
             <a:avLst/>
@@ -6883,7 +7180,7 @@
           <a:lstStyle/>
           <a:p>
             <a:r>
-              <a:rPr sz="1600" b="0">
+              <a:rPr sz="1400" b="0">
                 <a:solidFill>
                   <a:srgbClr val="062D3F"/>
                 </a:solidFill>
@@ -6894,37 +7191,16 @@
           </a:p>
         </p:txBody>
       </p:sp>
-      <p:cxnSp>
-        <p:nvCxnSpPr>
-          <p:cNvPr id="222" name="Разделитель"/>
-          <p:cNvCxnSpPr/>
-          <p:nvPr/>
-        </p:nvCxnSpPr>
-        <p:spPr>
-          <a:xfrm>
-            <a:off x="1069848" y="5257799"/>
-            <a:ext cx="16870679" cy="0"/>
-          </a:xfrm>
-          <a:prstGeom prst="line">
-            <a:avLst/>
-          </a:prstGeom>
-          <a:ln w="12700">
-            <a:solidFill>
-              <a:srgbClr val="D9DEE2"/>
-            </a:solidFill>
-          </a:ln>
-        </p:spPr>
-      </p:cxnSp>
-      <p:sp>
-        <p:nvSpPr>
-          <p:cNvPr id="223" name="Текст"/>
+      <p:sp>
+        <p:nvSpPr>
+          <p:cNvPr id="229" name="Текст"/>
           <p:cNvSpPr txBox="1"/>
           <p:nvPr/>
         </p:nvSpPr>
         <p:spPr>
           <a:xfrm>
-            <a:off x="1417320" y="5257799"/>
-            <a:ext cx="6766560" cy="658368"/>
+            <a:off x="13853160" y="4709160"/>
+            <a:ext cx="4023360" cy="676656"/>
           </a:xfrm>
           <a:prstGeom prst="rect">
             <a:avLst/>
@@ -6938,7 +7214,110 @@
           <a:lstStyle/>
           <a:p>
             <a:r>
-              <a:rPr sz="1700" b="1">
+              <a:rPr sz="1400" b="0">
+                <a:solidFill>
+                  <a:srgbClr val="062D3F"/>
+                </a:solidFill>
+                <a:latin typeface="Circe"/>
+              </a:rPr>
+              <a:t>ЕМИСС, БД ПМО</a:t>
+            </a:r>
+          </a:p>
+        </p:txBody>
+      </p:sp>
+      <p:sp>
+        <p:nvSpPr>
+          <p:cNvPr id="230" name="Полоса"/>
+          <p:cNvSpPr/>
+          <p:nvPr/>
+        </p:nvSpPr>
+        <p:spPr>
+          <a:xfrm>
+            <a:off x="1069848" y="5413248"/>
+            <a:ext cx="16870680" cy="621792"/>
+          </a:xfrm>
+          <a:prstGeom prst="roundRect">
+            <a:avLst>
+              <a:gd name="adj" fmla="val 30000"/>
+            </a:avLst>
+          </a:prstGeom>
+          <a:solidFill>
+            <a:srgbClr val="FFF3CC"/>
+          </a:solidFill>
+          <a:ln>
+            <a:noFill/>
+          </a:ln>
+        </p:spPr>
+        <p:txBody>
+          <a:bodyPr rtlCol="0" anchor="ctr"/>
+          <a:lstStyle/>
+          <a:p>
+            <a:pPr algn="ctr"/>
+          </a:p>
+        </p:txBody>
+      </p:sp>
+      <p:sp>
+        <p:nvSpPr>
+          <p:cNvPr id="231" name="Номер 5"/>
+          <p:cNvSpPr/>
+          <p:nvPr/>
+        </p:nvSpPr>
+        <p:spPr>
+          <a:xfrm>
+            <a:off x="1417320" y="5522976"/>
+            <a:ext cx="402336" cy="402336"/>
+          </a:xfrm>
+          <a:prstGeom prst="ellipse">
+            <a:avLst/>
+          </a:prstGeom>
+          <a:solidFill>
+            <a:srgbClr val="FFCC00"/>
+          </a:solidFill>
+          <a:ln>
+            <a:noFill/>
+          </a:ln>
+        </p:spPr>
+        <p:txBody>
+          <a:bodyPr rtlCol="0" anchor="ctr" lIns="0" rIns="0" tIns="0" bIns="0"/>
+          <a:lstStyle/>
+          <a:p>
+            <a:pPr algn="ctr"/>
+            <a:r>
+              <a:rPr sz="1500" b="1">
+                <a:solidFill>
+                  <a:srgbClr val="062D3F"/>
+                </a:solidFill>
+                <a:latin typeface="Circe Bold"/>
+              </a:rPr>
+              <a:t>5</a:t>
+            </a:r>
+          </a:p>
+        </p:txBody>
+      </p:sp>
+      <p:sp>
+        <p:nvSpPr>
+          <p:cNvPr id="232" name="Текст"/>
+          <p:cNvSpPr txBox="1"/>
+          <p:nvPr/>
+        </p:nvSpPr>
+        <p:spPr>
+          <a:xfrm>
+            <a:off x="2011680" y="5385816"/>
+            <a:ext cx="5029200" cy="676656"/>
+          </a:xfrm>
+          <a:prstGeom prst="rect">
+            <a:avLst/>
+          </a:prstGeom>
+          <a:noFill/>
+        </p:spPr>
+        <p:txBody>
+          <a:bodyPr wrap="square" anchor="ctr" lIns="0" rIns="0" tIns="0" bIns="0">
+            <a:spAutoFit/>
+          </a:bodyPr>
+          <a:lstStyle/>
+          <a:p>
+            <a:r>
+              <a:rPr sz="1500" b="1">
                 <a:solidFill>
                   <a:srgbClr val="062D3F"/>
                 </a:solidFill>
@@ -6951,14 +7330,14 @@
       </p:sp>
       <p:sp>
         <p:nvSpPr>
-          <p:cNvPr id="224" name="Текст"/>
+          <p:cNvPr id="233" name="Текст"/>
           <p:cNvSpPr txBox="1"/>
           <p:nvPr/>
         </p:nvSpPr>
         <p:spPr>
           <a:xfrm>
-            <a:off x="8412480" y="5257799"/>
-            <a:ext cx="3566160" cy="658368"/>
+            <a:off x="7178040" y="5385816"/>
+            <a:ext cx="2743200" cy="676656"/>
           </a:xfrm>
           <a:prstGeom prst="rect">
             <a:avLst/>
@@ -6972,9 +7351,9 @@
           <a:lstStyle/>
           <a:p>
             <a:r>
-              <a:rPr sz="1600" b="0">
+              <a:rPr sz="1400" b="0">
                 <a:solidFill>
-                  <a:srgbClr val="5E6B73"/>
+                  <a:srgbClr val="062D3F"/>
                 </a:solidFill>
                 <a:latin typeface="Circe"/>
               </a:rPr>
@@ -6985,14 +7364,14 @@
       </p:sp>
       <p:sp>
         <p:nvSpPr>
-          <p:cNvPr id="225" name="Текст"/>
+          <p:cNvPr id="234" name="Текст"/>
           <p:cNvSpPr txBox="1"/>
           <p:nvPr/>
         </p:nvSpPr>
         <p:spPr>
           <a:xfrm>
-            <a:off x="12252960" y="5257799"/>
-            <a:ext cx="5303520" cy="658368"/>
+            <a:off x="10058400" y="5385816"/>
+            <a:ext cx="3657600" cy="676656"/>
           </a:xfrm>
           <a:prstGeom prst="rect">
             <a:avLst/>
@@ -7006,7 +7385,7 @@
           <a:lstStyle/>
           <a:p>
             <a:r>
-              <a:rPr sz="1600" b="0">
+              <a:rPr sz="1400" b="0">
                 <a:solidFill>
                   <a:srgbClr val="062D3F"/>
                 </a:solidFill>
@@ -7017,37 +7396,16 @@
           </a:p>
         </p:txBody>
       </p:sp>
-      <p:cxnSp>
-        <p:nvCxnSpPr>
-          <p:cNvPr id="226" name="Разделитель"/>
-          <p:cNvCxnSpPr/>
-          <p:nvPr/>
-        </p:nvCxnSpPr>
-        <p:spPr>
-          <a:xfrm>
-            <a:off x="1069848" y="5916167"/>
-            <a:ext cx="16870679" cy="0"/>
-          </a:xfrm>
-          <a:prstGeom prst="line">
-            <a:avLst/>
-          </a:prstGeom>
-          <a:ln w="12700">
-            <a:solidFill>
-              <a:srgbClr val="D9DEE2"/>
-            </a:solidFill>
-          </a:ln>
-        </p:spPr>
-      </p:cxnSp>
-      <p:sp>
-        <p:nvSpPr>
-          <p:cNvPr id="227" name="Текст"/>
+      <p:sp>
+        <p:nvSpPr>
+          <p:cNvPr id="235" name="Текст"/>
           <p:cNvSpPr txBox="1"/>
           <p:nvPr/>
         </p:nvSpPr>
         <p:spPr>
           <a:xfrm>
-            <a:off x="1417320" y="5916167"/>
-            <a:ext cx="6766560" cy="658368"/>
+            <a:off x="13853160" y="5385816"/>
+            <a:ext cx="4023360" cy="676656"/>
           </a:xfrm>
           <a:prstGeom prst="rect">
             <a:avLst/>
@@ -7061,7 +7419,79 @@
           <a:lstStyle/>
           <a:p>
             <a:r>
-              <a:rPr sz="1700" b="1">
+              <a:rPr sz="1400" b="0">
+                <a:solidFill>
+                  <a:srgbClr val="062D3F"/>
+                </a:solidFill>
+                <a:latin typeface="Circe"/>
+              </a:rPr>
+              <a:t>Росстат, обследование рабочей силы по региону</a:t>
+            </a:r>
+          </a:p>
+        </p:txBody>
+      </p:sp>
+      <p:sp>
+        <p:nvSpPr>
+          <p:cNvPr id="236" name="Номер 6"/>
+          <p:cNvSpPr/>
+          <p:nvPr/>
+        </p:nvSpPr>
+        <p:spPr>
+          <a:xfrm>
+            <a:off x="1417320" y="6199632"/>
+            <a:ext cx="402336" cy="402336"/>
+          </a:xfrm>
+          <a:prstGeom prst="ellipse">
+            <a:avLst/>
+          </a:prstGeom>
+          <a:solidFill>
+            <a:srgbClr val="FFCC00"/>
+          </a:solidFill>
+          <a:ln>
+            <a:noFill/>
+          </a:ln>
+        </p:spPr>
+        <p:txBody>
+          <a:bodyPr rtlCol="0" anchor="ctr" lIns="0" rIns="0" tIns="0" bIns="0"/>
+          <a:lstStyle/>
+          <a:p>
+            <a:pPr algn="ctr"/>
+            <a:r>
+              <a:rPr sz="1500" b="1">
+                <a:solidFill>
+                  <a:srgbClr val="062D3F"/>
+                </a:solidFill>
+                <a:latin typeface="Circe Bold"/>
+              </a:rPr>
+              <a:t>6</a:t>
+            </a:r>
+          </a:p>
+        </p:txBody>
+      </p:sp>
+      <p:sp>
+        <p:nvSpPr>
+          <p:cNvPr id="237" name="Текст"/>
+          <p:cNvSpPr txBox="1"/>
+          <p:nvPr/>
+        </p:nvSpPr>
+        <p:spPr>
+          <a:xfrm>
+            <a:off x="2011680" y="6062472"/>
+            <a:ext cx="5029200" cy="676656"/>
+          </a:xfrm>
+          <a:prstGeom prst="rect">
+            <a:avLst/>
+          </a:prstGeom>
+          <a:noFill/>
+        </p:spPr>
+        <p:txBody>
+          <a:bodyPr wrap="square" anchor="ctr" lIns="0" rIns="0" tIns="0" bIns="0">
+            <a:spAutoFit/>
+          </a:bodyPr>
+          <a:lstStyle/>
+          <a:p>
+            <a:r>
+              <a:rPr sz="1500" b="1">
                 <a:solidFill>
                   <a:srgbClr val="062D3F"/>
                 </a:solidFill>
@@ -7074,14 +7504,14 @@
       </p:sp>
       <p:sp>
         <p:nvSpPr>
-          <p:cNvPr id="228" name="Текст"/>
+          <p:cNvPr id="238" name="Текст"/>
           <p:cNvSpPr txBox="1"/>
           <p:nvPr/>
         </p:nvSpPr>
         <p:spPr>
           <a:xfrm>
-            <a:off x="8412480" y="5916167"/>
-            <a:ext cx="3566160" cy="658368"/>
+            <a:off x="7178040" y="6062472"/>
+            <a:ext cx="2743200" cy="676656"/>
           </a:xfrm>
           <a:prstGeom prst="rect">
             <a:avLst/>
@@ -7095,9 +7525,9 @@
           <a:lstStyle/>
           <a:p>
             <a:r>
-              <a:rPr sz="1600" b="0">
+              <a:rPr sz="1400" b="0">
                 <a:solidFill>
-                  <a:srgbClr val="5E6B73"/>
+                  <a:srgbClr val="062D3F"/>
                 </a:solidFill>
                 <a:latin typeface="Circe"/>
               </a:rPr>
@@ -7108,14 +7538,14 @@
       </p:sp>
       <p:sp>
         <p:nvSpPr>
-          <p:cNvPr id="229" name="Текст"/>
+          <p:cNvPr id="239" name="Текст"/>
           <p:cNvSpPr txBox="1"/>
           <p:nvPr/>
         </p:nvSpPr>
         <p:spPr>
           <a:xfrm>
-            <a:off x="12252960" y="5916167"/>
-            <a:ext cx="5303520" cy="658368"/>
+            <a:off x="10058400" y="6062472"/>
+            <a:ext cx="3657600" cy="676656"/>
           </a:xfrm>
           <a:prstGeom prst="rect">
             <a:avLst/>
@@ -7129,7 +7559,7 @@
           <a:lstStyle/>
           <a:p>
             <a:r>
-              <a:rPr sz="1600" b="0">
+              <a:rPr sz="1400" b="0">
                 <a:solidFill>
                   <a:srgbClr val="062D3F"/>
                 </a:solidFill>
@@ -7140,37 +7570,16 @@
           </a:p>
         </p:txBody>
       </p:sp>
-      <p:cxnSp>
-        <p:nvCxnSpPr>
-          <p:cNvPr id="230" name="Разделитель"/>
-          <p:cNvCxnSpPr/>
-          <p:nvPr/>
-        </p:nvCxnSpPr>
-        <p:spPr>
-          <a:xfrm>
-            <a:off x="1069848" y="6574535"/>
-            <a:ext cx="16870679" cy="0"/>
-          </a:xfrm>
-          <a:prstGeom prst="line">
-            <a:avLst/>
-          </a:prstGeom>
-          <a:ln w="12700">
-            <a:solidFill>
-              <a:srgbClr val="D9DEE2"/>
-            </a:solidFill>
-          </a:ln>
-        </p:spPr>
-      </p:cxnSp>
-      <p:sp>
-        <p:nvSpPr>
-          <p:cNvPr id="231" name="Текст"/>
+      <p:sp>
+        <p:nvSpPr>
+          <p:cNvPr id="240" name="Текст"/>
           <p:cNvSpPr txBox="1"/>
           <p:nvPr/>
         </p:nvSpPr>
         <p:spPr>
           <a:xfrm>
-            <a:off x="1417320" y="6574535"/>
-            <a:ext cx="6766560" cy="658368"/>
+            <a:off x="13853160" y="6062472"/>
+            <a:ext cx="4023360" cy="676656"/>
           </a:xfrm>
           <a:prstGeom prst="rect">
             <a:avLst/>
@@ -7184,7 +7593,110 @@
           <a:lstStyle/>
           <a:p>
             <a:r>
-              <a:rPr sz="1700" b="1">
+              <a:rPr sz="1400" b="0">
+                <a:solidFill>
+                  <a:srgbClr val="062D3F"/>
+                </a:solidFill>
+                <a:latin typeface="Circe"/>
+              </a:rPr>
+              <a:t>Расчёт по продукту и занятости</a:t>
+            </a:r>
+          </a:p>
+        </p:txBody>
+      </p:sp>
+      <p:sp>
+        <p:nvSpPr>
+          <p:cNvPr id="241" name="Полоса"/>
+          <p:cNvSpPr/>
+          <p:nvPr/>
+        </p:nvSpPr>
+        <p:spPr>
+          <a:xfrm>
+            <a:off x="1069848" y="6766560"/>
+            <a:ext cx="16870680" cy="621792"/>
+          </a:xfrm>
+          <a:prstGeom prst="roundRect">
+            <a:avLst>
+              <a:gd name="adj" fmla="val 30000"/>
+            </a:avLst>
+          </a:prstGeom>
+          <a:solidFill>
+            <a:srgbClr val="FFF3CC"/>
+          </a:solidFill>
+          <a:ln>
+            <a:noFill/>
+          </a:ln>
+        </p:spPr>
+        <p:txBody>
+          <a:bodyPr rtlCol="0" anchor="ctr"/>
+          <a:lstStyle/>
+          <a:p>
+            <a:pPr algn="ctr"/>
+          </a:p>
+        </p:txBody>
+      </p:sp>
+      <p:sp>
+        <p:nvSpPr>
+          <p:cNvPr id="242" name="Номер 7"/>
+          <p:cNvSpPr/>
+          <p:nvPr/>
+        </p:nvSpPr>
+        <p:spPr>
+          <a:xfrm>
+            <a:off x="1417320" y="6876288"/>
+            <a:ext cx="402336" cy="402336"/>
+          </a:xfrm>
+          <a:prstGeom prst="ellipse">
+            <a:avLst/>
+          </a:prstGeom>
+          <a:solidFill>
+            <a:srgbClr val="FFCC00"/>
+          </a:solidFill>
+          <a:ln>
+            <a:noFill/>
+          </a:ln>
+        </p:spPr>
+        <p:txBody>
+          <a:bodyPr rtlCol="0" anchor="ctr" lIns="0" rIns="0" tIns="0" bIns="0"/>
+          <a:lstStyle/>
+          <a:p>
+            <a:pPr algn="ctr"/>
+            <a:r>
+              <a:rPr sz="1500" b="1">
+                <a:solidFill>
+                  <a:srgbClr val="062D3F"/>
+                </a:solidFill>
+                <a:latin typeface="Circe Bold"/>
+              </a:rPr>
+              <a:t>7</a:t>
+            </a:r>
+          </a:p>
+        </p:txBody>
+      </p:sp>
+      <p:sp>
+        <p:nvSpPr>
+          <p:cNvPr id="243" name="Текст"/>
+          <p:cNvSpPr txBox="1"/>
+          <p:nvPr/>
+        </p:nvSpPr>
+        <p:spPr>
+          <a:xfrm>
+            <a:off x="2011680" y="6739128"/>
+            <a:ext cx="5029200" cy="676656"/>
+          </a:xfrm>
+          <a:prstGeom prst="rect">
+            <a:avLst/>
+          </a:prstGeom>
+          <a:noFill/>
+        </p:spPr>
+        <p:txBody>
+          <a:bodyPr wrap="square" anchor="ctr" lIns="0" rIns="0" tIns="0" bIns="0">
+            <a:spAutoFit/>
+          </a:bodyPr>
+          <a:lstStyle/>
+          <a:p>
+            <a:r>
+              <a:rPr sz="1500" b="1">
                 <a:solidFill>
                   <a:srgbClr val="062D3F"/>
                 </a:solidFill>
@@ -7197,14 +7709,14 @@
       </p:sp>
       <p:sp>
         <p:nvSpPr>
-          <p:cNvPr id="232" name="Текст"/>
+          <p:cNvPr id="244" name="Текст"/>
           <p:cNvSpPr txBox="1"/>
           <p:nvPr/>
         </p:nvSpPr>
         <p:spPr>
           <a:xfrm>
-            <a:off x="8412480" y="6574535"/>
-            <a:ext cx="3566160" cy="658368"/>
+            <a:off x="7178040" y="6739128"/>
+            <a:ext cx="2743200" cy="676656"/>
           </a:xfrm>
           <a:prstGeom prst="rect">
             <a:avLst/>
@@ -7218,9 +7730,9 @@
           <a:lstStyle/>
           <a:p>
             <a:r>
-              <a:rPr sz="1600" b="0">
+              <a:rPr sz="1400" b="0">
                 <a:solidFill>
-                  <a:srgbClr val="5E6B73"/>
+                  <a:srgbClr val="062D3F"/>
                 </a:solidFill>
                 <a:latin typeface="Circe"/>
               </a:rPr>
@@ -7231,14 +7743,14 @@
       </p:sp>
       <p:sp>
         <p:nvSpPr>
-          <p:cNvPr id="233" name="Текст"/>
+          <p:cNvPr id="245" name="Текст"/>
           <p:cNvSpPr txBox="1"/>
           <p:nvPr/>
         </p:nvSpPr>
         <p:spPr>
           <a:xfrm>
-            <a:off x="12252960" y="6574535"/>
-            <a:ext cx="5303520" cy="658368"/>
+            <a:off x="10058400" y="6739128"/>
+            <a:ext cx="3657600" cy="676656"/>
           </a:xfrm>
           <a:prstGeom prst="rect">
             <a:avLst/>
@@ -7252,7 +7764,7 @@
           <a:lstStyle/>
           <a:p>
             <a:r>
-              <a:rPr sz="1600" b="0">
+              <a:rPr sz="1400" b="0">
                 <a:solidFill>
                   <a:srgbClr val="062D3F"/>
                 </a:solidFill>
@@ -7263,37 +7775,16 @@
           </a:p>
         </p:txBody>
       </p:sp>
-      <p:cxnSp>
-        <p:nvCxnSpPr>
-          <p:cNvPr id="234" name="Разделитель"/>
-          <p:cNvCxnSpPr/>
-          <p:nvPr/>
-        </p:nvCxnSpPr>
-        <p:spPr>
-          <a:xfrm>
-            <a:off x="1069848" y="7232903"/>
-            <a:ext cx="16870679" cy="0"/>
-          </a:xfrm>
-          <a:prstGeom prst="line">
-            <a:avLst/>
-          </a:prstGeom>
-          <a:ln w="12700">
-            <a:solidFill>
-              <a:srgbClr val="D9DEE2"/>
-            </a:solidFill>
-          </a:ln>
-        </p:spPr>
-      </p:cxnSp>
-      <p:sp>
-        <p:nvSpPr>
-          <p:cNvPr id="235" name="Текст"/>
+      <p:sp>
+        <p:nvSpPr>
+          <p:cNvPr id="246" name="Текст"/>
           <p:cNvSpPr txBox="1"/>
           <p:nvPr/>
         </p:nvSpPr>
         <p:spPr>
           <a:xfrm>
-            <a:off x="1417320" y="7232903"/>
-            <a:ext cx="6766560" cy="658368"/>
+            <a:off x="13853160" y="6739128"/>
+            <a:ext cx="4023360" cy="676656"/>
           </a:xfrm>
           <a:prstGeom prst="rect">
             <a:avLst/>
@@ -7307,7 +7798,79 @@
           <a:lstStyle/>
           <a:p>
             <a:r>
-              <a:rPr sz="1700" b="1">
+              <a:rPr sz="1400" b="0">
+                <a:solidFill>
+                  <a:srgbClr val="062D3F"/>
+                </a:solidFill>
+                <a:latin typeface="Circe"/>
+              </a:rPr>
+              <a:t>Росстат по региону, ЕМИСС</a:t>
+            </a:r>
+          </a:p>
+        </p:txBody>
+      </p:sp>
+      <p:sp>
+        <p:nvSpPr>
+          <p:cNvPr id="247" name="Номер 8"/>
+          <p:cNvSpPr/>
+          <p:nvPr/>
+        </p:nvSpPr>
+        <p:spPr>
+          <a:xfrm>
+            <a:off x="1417320" y="7552944"/>
+            <a:ext cx="402336" cy="402336"/>
+          </a:xfrm>
+          <a:prstGeom prst="ellipse">
+            <a:avLst/>
+          </a:prstGeom>
+          <a:solidFill>
+            <a:srgbClr val="FFCC00"/>
+          </a:solidFill>
+          <a:ln>
+            <a:noFill/>
+          </a:ln>
+        </p:spPr>
+        <p:txBody>
+          <a:bodyPr rtlCol="0" anchor="ctr" lIns="0" rIns="0" tIns="0" bIns="0"/>
+          <a:lstStyle/>
+          <a:p>
+            <a:pPr algn="ctr"/>
+            <a:r>
+              <a:rPr sz="1500" b="1">
+                <a:solidFill>
+                  <a:srgbClr val="062D3F"/>
+                </a:solidFill>
+                <a:latin typeface="Circe Bold"/>
+              </a:rPr>
+              <a:t>8</a:t>
+            </a:r>
+          </a:p>
+        </p:txBody>
+      </p:sp>
+      <p:sp>
+        <p:nvSpPr>
+          <p:cNvPr id="248" name="Текст"/>
+          <p:cNvSpPr txBox="1"/>
+          <p:nvPr/>
+        </p:nvSpPr>
+        <p:spPr>
+          <a:xfrm>
+            <a:off x="2011680" y="7415784"/>
+            <a:ext cx="5029200" cy="676656"/>
+          </a:xfrm>
+          <a:prstGeom prst="rect">
+            <a:avLst/>
+          </a:prstGeom>
+          <a:noFill/>
+        </p:spPr>
+        <p:txBody>
+          <a:bodyPr wrap="square" anchor="ctr" lIns="0" rIns="0" tIns="0" bIns="0">
+            <a:spAutoFit/>
+          </a:bodyPr>
+          <a:lstStyle/>
+          <a:p>
+            <a:r>
+              <a:rPr sz="1500" b="1">
                 <a:solidFill>
                   <a:srgbClr val="062D3F"/>
                 </a:solidFill>
@@ -7320,14 +7883,14 @@
       </p:sp>
       <p:sp>
         <p:nvSpPr>
-          <p:cNvPr id="236" name="Текст"/>
+          <p:cNvPr id="249" name="Текст"/>
           <p:cNvSpPr txBox="1"/>
           <p:nvPr/>
         </p:nvSpPr>
         <p:spPr>
           <a:xfrm>
-            <a:off x="8412480" y="7232903"/>
-            <a:ext cx="3566160" cy="658368"/>
+            <a:off x="7178040" y="7415784"/>
+            <a:ext cx="2743200" cy="676656"/>
           </a:xfrm>
           <a:prstGeom prst="rect">
             <a:avLst/>
@@ -7341,9 +7904,9 @@
           <a:lstStyle/>
           <a:p>
             <a:r>
-              <a:rPr sz="1600" b="0">
+              <a:rPr sz="1400" b="0">
                 <a:solidFill>
-                  <a:srgbClr val="5E6B73"/>
+                  <a:srgbClr val="062D3F"/>
                 </a:solidFill>
                 <a:latin typeface="Circe"/>
               </a:rPr>
@@ -7354,14 +7917,14 @@
       </p:sp>
       <p:sp>
         <p:nvSpPr>
-          <p:cNvPr id="237" name="Текст"/>
+          <p:cNvPr id="250" name="Текст"/>
           <p:cNvSpPr txBox="1"/>
           <p:nvPr/>
         </p:nvSpPr>
         <p:spPr>
           <a:xfrm>
-            <a:off x="12252960" y="7232903"/>
-            <a:ext cx="5303520" cy="658368"/>
+            <a:off x="10058400" y="7415784"/>
+            <a:ext cx="3657600" cy="676656"/>
           </a:xfrm>
           <a:prstGeom prst="rect">
             <a:avLst/>
@@ -7375,7 +7938,7 @@
           <a:lstStyle/>
           <a:p>
             <a:r>
-              <a:rPr sz="1600" b="0">
+              <a:rPr sz="1400" b="0">
                 <a:solidFill>
                   <a:srgbClr val="062D3F"/>
                 </a:solidFill>
@@ -7386,37 +7949,16 @@
           </a:p>
         </p:txBody>
       </p:sp>
-      <p:cxnSp>
-        <p:nvCxnSpPr>
-          <p:cNvPr id="238" name="Разделитель"/>
-          <p:cNvCxnSpPr/>
-          <p:nvPr/>
-        </p:nvCxnSpPr>
-        <p:spPr>
-          <a:xfrm>
-            <a:off x="1069848" y="7891271"/>
-            <a:ext cx="16870679" cy="0"/>
-          </a:xfrm>
-          <a:prstGeom prst="line">
-            <a:avLst/>
-          </a:prstGeom>
-          <a:ln w="12700">
-            <a:solidFill>
-              <a:srgbClr val="D9DEE2"/>
-            </a:solidFill>
-          </a:ln>
-        </p:spPr>
-      </p:cxnSp>
-      <p:sp>
-        <p:nvSpPr>
-          <p:cNvPr id="239" name="Текст"/>
+      <p:sp>
+        <p:nvSpPr>
+          <p:cNvPr id="251" name="Текст"/>
           <p:cNvSpPr txBox="1"/>
           <p:nvPr/>
         </p:nvSpPr>
         <p:spPr>
           <a:xfrm>
-            <a:off x="1417320" y="7891271"/>
-            <a:ext cx="6766560" cy="658368"/>
+            <a:off x="13853160" y="7415784"/>
+            <a:ext cx="4023360" cy="676656"/>
           </a:xfrm>
           <a:prstGeom prst="rect">
             <a:avLst/>
@@ -7430,7 +7972,110 @@
           <a:lstStyle/>
           <a:p>
             <a:r>
-              <a:rPr sz="1700" b="1">
+              <a:rPr sz="1400" b="0">
+                <a:solidFill>
+                  <a:srgbClr val="062D3F"/>
+                </a:solidFill>
+                <a:latin typeface="Circe"/>
+              </a:rPr>
+              <a:t>БД ПМО, ЕМИСС</a:t>
+            </a:r>
+          </a:p>
+        </p:txBody>
+      </p:sp>
+      <p:sp>
+        <p:nvSpPr>
+          <p:cNvPr id="252" name="Полоса"/>
+          <p:cNvSpPr/>
+          <p:nvPr/>
+        </p:nvSpPr>
+        <p:spPr>
+          <a:xfrm>
+            <a:off x="1069848" y="8119872"/>
+            <a:ext cx="16870680" cy="621792"/>
+          </a:xfrm>
+          <a:prstGeom prst="roundRect">
+            <a:avLst>
+              <a:gd name="adj" fmla="val 30000"/>
+            </a:avLst>
+          </a:prstGeom>
+          <a:solidFill>
+            <a:srgbClr val="FFF3CC"/>
+          </a:solidFill>
+          <a:ln>
+            <a:noFill/>
+          </a:ln>
+        </p:spPr>
+        <p:txBody>
+          <a:bodyPr rtlCol="0" anchor="ctr"/>
+          <a:lstStyle/>
+          <a:p>
+            <a:pPr algn="ctr"/>
+          </a:p>
+        </p:txBody>
+      </p:sp>
+      <p:sp>
+        <p:nvSpPr>
+          <p:cNvPr id="253" name="Номер 9"/>
+          <p:cNvSpPr/>
+          <p:nvPr/>
+        </p:nvSpPr>
+        <p:spPr>
+          <a:xfrm>
+            <a:off x="1417320" y="8229600"/>
+            <a:ext cx="402336" cy="402336"/>
+          </a:xfrm>
+          <a:prstGeom prst="ellipse">
+            <a:avLst/>
+          </a:prstGeom>
+          <a:solidFill>
+            <a:srgbClr val="FFCC00"/>
+          </a:solidFill>
+          <a:ln>
+            <a:noFill/>
+          </a:ln>
+        </p:spPr>
+        <p:txBody>
+          <a:bodyPr rtlCol="0" anchor="ctr" lIns="0" rIns="0" tIns="0" bIns="0"/>
+          <a:lstStyle/>
+          <a:p>
+            <a:pPr algn="ctr"/>
+            <a:r>
+              <a:rPr sz="1500" b="1">
+                <a:solidFill>
+                  <a:srgbClr val="062D3F"/>
+                </a:solidFill>
+                <a:latin typeface="Circe Bold"/>
+              </a:rPr>
+              <a:t>9</a:t>
+            </a:r>
+          </a:p>
+        </p:txBody>
+      </p:sp>
+      <p:sp>
+        <p:nvSpPr>
+          <p:cNvPr id="254" name="Текст"/>
+          <p:cNvSpPr txBox="1"/>
+          <p:nvPr/>
+        </p:nvSpPr>
+        <p:spPr>
+          <a:xfrm>
+            <a:off x="2011680" y="8092440"/>
+            <a:ext cx="5029200" cy="676656"/>
+          </a:xfrm>
+          <a:prstGeom prst="rect">
+            <a:avLst/>
+          </a:prstGeom>
+          <a:noFill/>
+        </p:spPr>
+        <p:txBody>
+          <a:bodyPr wrap="square" anchor="ctr" lIns="0" rIns="0" tIns="0" bIns="0">
+            <a:spAutoFit/>
+          </a:bodyPr>
+          <a:lstStyle/>
+          <a:p>
+            <a:r>
+              <a:rPr sz="1500" b="1">
                 <a:solidFill>
                   <a:srgbClr val="062D3F"/>
                 </a:solidFill>
@@ -7443,14 +8088,14 @@
       </p:sp>
       <p:sp>
         <p:nvSpPr>
-          <p:cNvPr id="240" name="Текст"/>
+          <p:cNvPr id="255" name="Текст"/>
           <p:cNvSpPr txBox="1"/>
           <p:nvPr/>
         </p:nvSpPr>
         <p:spPr>
           <a:xfrm>
-            <a:off x="8412480" y="7891271"/>
-            <a:ext cx="3566160" cy="658368"/>
+            <a:off x="7178040" y="8092440"/>
+            <a:ext cx="2743200" cy="676656"/>
           </a:xfrm>
           <a:prstGeom prst="rect">
             <a:avLst/>
@@ -7464,9 +8109,9 @@
           <a:lstStyle/>
           <a:p>
             <a:r>
-              <a:rPr sz="1600" b="0">
+              <a:rPr sz="1400" b="0">
                 <a:solidFill>
-                  <a:srgbClr val="5E6B73"/>
+                  <a:srgbClr val="062D3F"/>
                 </a:solidFill>
                 <a:latin typeface="Circe"/>
               </a:rPr>
@@ -7477,14 +8122,14 @@
       </p:sp>
       <p:sp>
         <p:nvSpPr>
-          <p:cNvPr id="241" name="Текст"/>
+          <p:cNvPr id="256" name="Текст"/>
           <p:cNvSpPr txBox="1"/>
           <p:nvPr/>
         </p:nvSpPr>
         <p:spPr>
           <a:xfrm>
-            <a:off x="12252960" y="7891271"/>
-            <a:ext cx="5303520" cy="658368"/>
+            <a:off x="10058400" y="8092440"/>
+            <a:ext cx="3657600" cy="676656"/>
           </a:xfrm>
           <a:prstGeom prst="rect">
             <a:avLst/>
@@ -7498,7 +8143,7 @@
           <a:lstStyle/>
           <a:p>
             <a:r>
-              <a:rPr sz="1600" b="0">
+              <a:rPr sz="1400" b="0">
                 <a:solidFill>
                   <a:srgbClr val="062D3F"/>
                 </a:solidFill>
@@ -7509,37 +8154,16 @@
           </a:p>
         </p:txBody>
       </p:sp>
-      <p:cxnSp>
-        <p:nvCxnSpPr>
-          <p:cNvPr id="242" name="Разделитель"/>
-          <p:cNvCxnSpPr/>
-          <p:nvPr/>
-        </p:nvCxnSpPr>
-        <p:spPr>
-          <a:xfrm>
-            <a:off x="1069848" y="8549640"/>
-            <a:ext cx="16870679" cy="0"/>
-          </a:xfrm>
-          <a:prstGeom prst="line">
-            <a:avLst/>
-          </a:prstGeom>
-          <a:ln w="12700">
-            <a:solidFill>
-              <a:srgbClr val="D9DEE2"/>
-            </a:solidFill>
-          </a:ln>
-        </p:spPr>
-      </p:cxnSp>
-      <p:sp>
-        <p:nvSpPr>
-          <p:cNvPr id="243" name="Текст"/>
+      <p:sp>
+        <p:nvSpPr>
+          <p:cNvPr id="257" name="Текст"/>
           <p:cNvSpPr txBox="1"/>
           <p:nvPr/>
         </p:nvSpPr>
         <p:spPr>
           <a:xfrm>
-            <a:off x="1417320" y="8549640"/>
-            <a:ext cx="6766560" cy="658368"/>
+            <a:off x="13853160" y="8092440"/>
+            <a:ext cx="4023360" cy="676656"/>
           </a:xfrm>
           <a:prstGeom prst="rect">
             <a:avLst/>
@@ -7553,7 +8177,79 @@
           <a:lstStyle/>
           <a:p>
             <a:r>
-              <a:rPr sz="1700" b="1">
+              <a:rPr sz="1400" b="0">
+                <a:solidFill>
+                  <a:srgbClr val="062D3F"/>
+                </a:solidFill>
+                <a:latin typeface="Circe"/>
+              </a:rPr>
+              <a:t>БД ПМО, отчёт об исполнении бюджета</a:t>
+            </a:r>
+          </a:p>
+        </p:txBody>
+      </p:sp>
+      <p:sp>
+        <p:nvSpPr>
+          <p:cNvPr id="258" name="Номер 10"/>
+          <p:cNvSpPr/>
+          <p:nvPr/>
+        </p:nvSpPr>
+        <p:spPr>
+          <a:xfrm>
+            <a:off x="1417320" y="8906256"/>
+            <a:ext cx="402336" cy="402336"/>
+          </a:xfrm>
+          <a:prstGeom prst="ellipse">
+            <a:avLst/>
+          </a:prstGeom>
+          <a:solidFill>
+            <a:srgbClr val="FFCC00"/>
+          </a:solidFill>
+          <a:ln>
+            <a:noFill/>
+          </a:ln>
+        </p:spPr>
+        <p:txBody>
+          <a:bodyPr rtlCol="0" anchor="ctr" lIns="0" rIns="0" tIns="0" bIns="0"/>
+          <a:lstStyle/>
+          <a:p>
+            <a:pPr algn="ctr"/>
+            <a:r>
+              <a:rPr sz="1500" b="1">
+                <a:solidFill>
+                  <a:srgbClr val="062D3F"/>
+                </a:solidFill>
+                <a:latin typeface="Circe Bold"/>
+              </a:rPr>
+              <a:t>10</a:t>
+            </a:r>
+          </a:p>
+        </p:txBody>
+      </p:sp>
+      <p:sp>
+        <p:nvSpPr>
+          <p:cNvPr id="259" name="Текст"/>
+          <p:cNvSpPr txBox="1"/>
+          <p:nvPr/>
+        </p:nvSpPr>
+        <p:spPr>
+          <a:xfrm>
+            <a:off x="2011680" y="8769096"/>
+            <a:ext cx="5029200" cy="676656"/>
+          </a:xfrm>
+          <a:prstGeom prst="rect">
+            <a:avLst/>
+          </a:prstGeom>
+          <a:noFill/>
+        </p:spPr>
+        <p:txBody>
+          <a:bodyPr wrap="square" anchor="ctr" lIns="0" rIns="0" tIns="0" bIns="0">
+            <a:spAutoFit/>
+          </a:bodyPr>
+          <a:lstStyle/>
+          <a:p>
+            <a:r>
+              <a:rPr sz="1500" b="1">
                 <a:solidFill>
                   <a:srgbClr val="062D3F"/>
                 </a:solidFill>
@@ -7566,14 +8262,14 @@
       </p:sp>
       <p:sp>
         <p:nvSpPr>
-          <p:cNvPr id="244" name="Текст"/>
+          <p:cNvPr id="260" name="Текст"/>
           <p:cNvSpPr txBox="1"/>
           <p:nvPr/>
         </p:nvSpPr>
         <p:spPr>
           <a:xfrm>
-            <a:off x="8412480" y="8549640"/>
-            <a:ext cx="3566160" cy="658368"/>
+            <a:off x="7178040" y="8769096"/>
+            <a:ext cx="2743200" cy="676656"/>
           </a:xfrm>
           <a:prstGeom prst="rect">
             <a:avLst/>
@@ -7587,9 +8283,9 @@
           <a:lstStyle/>
           <a:p>
             <a:r>
-              <a:rPr sz="1600" b="0">
+              <a:rPr sz="1400" b="0">
                 <a:solidFill>
-                  <a:srgbClr val="5E6B73"/>
+                  <a:srgbClr val="062D3F"/>
                 </a:solidFill>
                 <a:latin typeface="Circe"/>
               </a:rPr>
@@ -7600,14 +8296,14 @@
       </p:sp>
       <p:sp>
         <p:nvSpPr>
-          <p:cNvPr id="245" name="Текст"/>
+          <p:cNvPr id="261" name="Текст"/>
           <p:cNvSpPr txBox="1"/>
           <p:nvPr/>
         </p:nvSpPr>
         <p:spPr>
           <a:xfrm>
-            <a:off x="12252960" y="8549640"/>
-            <a:ext cx="5303520" cy="658368"/>
+            <a:off x="10058400" y="8769096"/>
+            <a:ext cx="3657600" cy="676656"/>
           </a:xfrm>
           <a:prstGeom prst="rect">
             <a:avLst/>
@@ -7621,7 +8317,7 @@
           <a:lstStyle/>
           <a:p>
             <a:r>
-              <a:rPr sz="1600" b="0">
+              <a:rPr sz="1400" b="0">
                 <a:solidFill>
                   <a:srgbClr val="062D3F"/>
                 </a:solidFill>
@@ -7632,27 +8328,40 @@
           </a:p>
         </p:txBody>
       </p:sp>
-      <p:cxnSp>
-        <p:nvCxnSpPr>
-          <p:cNvPr id="246" name="Разделитель"/>
-          <p:cNvCxnSpPr/>
+      <p:sp>
+        <p:nvSpPr>
+          <p:cNvPr id="262" name="Текст"/>
+          <p:cNvSpPr txBox="1"/>
           <p:nvPr/>
-        </p:nvCxnSpPr>
-        <p:spPr>
-          <a:xfrm>
-            <a:off x="1069848" y="9208008"/>
-            <a:ext cx="16870679" cy="0"/>
-          </a:xfrm>
-          <a:prstGeom prst="line">
+        </p:nvSpPr>
+        <p:spPr>
+          <a:xfrm>
+            <a:off x="13853160" y="8769096"/>
+            <a:ext cx="4023360" cy="676656"/>
+          </a:xfrm>
+          <a:prstGeom prst="rect">
             <a:avLst/>
           </a:prstGeom>
-          <a:ln w="12700">
-            <a:solidFill>
-              <a:srgbClr val="D9DEE2"/>
-            </a:solidFill>
-          </a:ln>
-        </p:spPr>
-      </p:cxnSp>
+          <a:noFill/>
+        </p:spPr>
+        <p:txBody>
+          <a:bodyPr wrap="square" anchor="ctr" lIns="0" rIns="0" tIns="0" bIns="0">
+            <a:spAutoFit/>
+          </a:bodyPr>
+          <a:lstStyle/>
+          <a:p>
+            <a:r>
+              <a:rPr sz="1400" b="0">
+                <a:solidFill>
+                  <a:srgbClr val="062D3F"/>
+                </a:solidFill>
+                <a:latin typeface="Circe"/>
+              </a:rPr>
+              <a:t>Росстат по региону, расчёт по муниципалитету</a:t>
+            </a:r>
+          </a:p>
+        </p:txBody>
+      </p:sp>
     </p:spTree>
   </p:cSld>
   <p:clrMapOvr>

</xml_diff>